<commit_message>
Update CSEP23605 Review 1 presentation in documentation
</commit_message>
<xml_diff>
--- a/Documentation/PPT/CSEP23605 Review 1.pptx
+++ b/Documentation/PPT/CSEP23605 Review 1.pptx
@@ -217,7 +217,7 @@
           <a:p>
             <a:fld id="{830881A4-97E0-4626-BA30-074D23D3B5E2}" type="datetimeFigureOut">
               <a:rPr lang="en-IN" smtClean="0"/>
-              <a:t>11-03-2026</a:t>
+              <a:t>12-03-2026</a:t>
             </a:fld>
             <a:endParaRPr lang="en-IN"/>
           </a:p>
@@ -13126,7 +13126,7 @@
         <p:spPr>
           <a:xfrm>
             <a:off x="580072" y="1332845"/>
-            <a:ext cx="10769917" cy="1045223"/>
+            <a:ext cx="10769917" cy="2568717"/>
           </a:xfrm>
           <a:prstGeom prst="rect">
             <a:avLst/>
@@ -13151,7 +13151,7 @@
                 <a:latin typeface="Cambria" panose="02040503050406030204" pitchFamily="18" charset="0"/>
                 <a:ea typeface="Cambria" panose="02040503050406030204" pitchFamily="18" charset="0"/>
               </a:rPr>
-              <a:t>List the objectives (at least 4 – 5 objectives of the project)</a:t>
+              <a:t>To design and implement a secure CI/CD pipeline </a:t>
             </a:r>
           </a:p>
           <a:p>
@@ -13167,7 +13167,55 @@
                 <a:latin typeface="Cambria" panose="02040503050406030204" pitchFamily="18" charset="0"/>
                 <a:ea typeface="Cambria" panose="02040503050406030204" pitchFamily="18" charset="0"/>
               </a:rPr>
-              <a:t>Focus should be on the points that can be implemented and achievable </a:t>
+              <a:t>To integrate security testing tools into DevOps workflows </a:t>
+            </a:r>
+          </a:p>
+          <a:p>
+            <a:pPr marL="342900" indent="-342900">
+              <a:lnSpc>
+                <a:spcPct val="150000"/>
+              </a:lnSpc>
+              <a:buFont typeface="Arial" panose="020B0604020202020204" pitchFamily="34" charset="0"/>
+              <a:buChar char="•"/>
+            </a:pPr>
+            <a:r>
+              <a:rPr lang="en-US" sz="2200" dirty="0">
+                <a:latin typeface="Cambria" panose="02040503050406030204" pitchFamily="18" charset="0"/>
+                <a:ea typeface="Cambria" panose="02040503050406030204" pitchFamily="18" charset="0"/>
+              </a:rPr>
+              <a:t>To identify and mitigate vulnerabilities at early stages of development </a:t>
+            </a:r>
+          </a:p>
+          <a:p>
+            <a:pPr marL="342900" indent="-342900">
+              <a:lnSpc>
+                <a:spcPct val="150000"/>
+              </a:lnSpc>
+              <a:buFont typeface="Arial" panose="020B0604020202020204" pitchFamily="34" charset="0"/>
+              <a:buChar char="•"/>
+            </a:pPr>
+            <a:r>
+              <a:rPr lang="en-US" sz="2200" dirty="0">
+                <a:latin typeface="Cambria" panose="02040503050406030204" pitchFamily="18" charset="0"/>
+                <a:ea typeface="Cambria" panose="02040503050406030204" pitchFamily="18" charset="0"/>
+              </a:rPr>
+              <a:t>To reduce security risks and remediation costs </a:t>
+            </a:r>
+          </a:p>
+          <a:p>
+            <a:pPr marL="342900" indent="-342900">
+              <a:lnSpc>
+                <a:spcPct val="150000"/>
+              </a:lnSpc>
+              <a:buFont typeface="Arial" panose="020B0604020202020204" pitchFamily="34" charset="0"/>
+              <a:buChar char="•"/>
+            </a:pPr>
+            <a:r>
+              <a:rPr lang="en-US" sz="2200" dirty="0">
+                <a:latin typeface="Cambria" panose="02040503050406030204" pitchFamily="18" charset="0"/>
+                <a:ea typeface="Cambria" panose="02040503050406030204" pitchFamily="18" charset="0"/>
+              </a:rPr>
+              <a:t>To ensure faster and secure software delivery </a:t>
             </a:r>
             <a:endParaRPr lang="en-IN" sz="2200" dirty="0">
               <a:latin typeface="Cambria" panose="02040503050406030204" pitchFamily="18" charset="0"/>

</xml_diff>

<commit_message>
Update CSEP23605 Review 1.pptx with new content
</commit_message>
<xml_diff>
--- a/Documentation/PPT/CSEP23605 Review 1.pptx
+++ b/Documentation/PPT/CSEP23605 Review 1.pptx
@@ -5,7 +5,7 @@
     <p:sldMasterId id="2147483648" r:id="rId1"/>
   </p:sldMasterIdLst>
   <p:notesMasterIdLst>
-    <p:notesMasterId r:id="rId28"/>
+    <p:notesMasterId r:id="rId33"/>
   </p:notesMasterIdLst>
   <p:sldIdLst>
     <p:sldId id="256" r:id="rId2"/>
@@ -26,14 +26,19 @@
     <p:sldId id="275" r:id="rId17"/>
     <p:sldId id="284" r:id="rId18"/>
     <p:sldId id="285" r:id="rId19"/>
-    <p:sldId id="261" r:id="rId20"/>
-    <p:sldId id="286" r:id="rId21"/>
-    <p:sldId id="287" r:id="rId22"/>
-    <p:sldId id="276" r:id="rId23"/>
-    <p:sldId id="288" r:id="rId24"/>
-    <p:sldId id="289" r:id="rId25"/>
-    <p:sldId id="263" r:id="rId26"/>
-    <p:sldId id="264" r:id="rId27"/>
+    <p:sldId id="290" r:id="rId20"/>
+    <p:sldId id="291" r:id="rId21"/>
+    <p:sldId id="292" r:id="rId22"/>
+    <p:sldId id="293" r:id="rId23"/>
+    <p:sldId id="294" r:id="rId24"/>
+    <p:sldId id="261" r:id="rId25"/>
+    <p:sldId id="286" r:id="rId26"/>
+    <p:sldId id="287" r:id="rId27"/>
+    <p:sldId id="276" r:id="rId28"/>
+    <p:sldId id="288" r:id="rId29"/>
+    <p:sldId id="289" r:id="rId30"/>
+    <p:sldId id="263" r:id="rId31"/>
+    <p:sldId id="264" r:id="rId32"/>
   </p:sldIdLst>
   <p:sldSz cx="12192000" cy="6858000"/>
   <p:notesSz cx="6858000" cy="9144000"/>
@@ -222,7 +227,7 @@
           <a:p>
             <a:fld id="{830881A4-97E0-4626-BA30-074D23D3B5E2}" type="datetimeFigureOut">
               <a:rPr lang="en-IN" smtClean="0"/>
-              <a:t>13-03-2026</a:t>
+              <a:t>19-05-2026</a:t>
             </a:fld>
             <a:endParaRPr lang="en-IN"/>
           </a:p>
@@ -5857,10 +5862,10 @@
       </p:sp>
       <p:pic>
         <p:nvPicPr>
-          <p:cNvPr id="10" name="Picture 9">
+          <p:cNvPr id="7" name="Picture 6">
             <a:extLst>
               <a:ext uri="{FF2B5EF4-FFF2-40B4-BE49-F238E27FC236}">
-                <a16:creationId xmlns:a16="http://schemas.microsoft.com/office/drawing/2014/main" id="{978F5486-85E0-64E3-7C12-07D51C8C02C2}"/>
+                <a16:creationId xmlns:a16="http://schemas.microsoft.com/office/drawing/2014/main" id="{819157BB-4224-AE02-A6FA-B80065D7327A}"/>
               </a:ext>
             </a:extLst>
           </p:cNvPr>
@@ -5883,12 +5888,17 @@
         </p:blipFill>
         <p:spPr>
           <a:xfrm>
-            <a:off x="6096000" y="1353788"/>
-            <a:ext cx="5931477" cy="3421412"/>
+            <a:off x="6096000" y="1982175"/>
+            <a:ext cx="5996908" cy="2654311"/>
           </a:xfrm>
           <a:prstGeom prst="rect">
             <a:avLst/>
           </a:prstGeom>
+          <a:ln>
+            <a:solidFill>
+              <a:schemeClr val="tx1"/>
+            </a:solidFill>
+          </a:ln>
         </p:spPr>
       </p:pic>
     </p:spTree>
@@ -7946,7 +7956,13 @@
       </p:grpSpPr>
       <p:sp>
         <p:nvSpPr>
-          <p:cNvPr id="2" name="Footer Placeholder 1"/>
+          <p:cNvPr id="2" name="Footer Placeholder 1">
+            <a:extLst>
+              <a:ext uri="{FF2B5EF4-FFF2-40B4-BE49-F238E27FC236}">
+                <a16:creationId xmlns:a16="http://schemas.microsoft.com/office/drawing/2014/main" id="{17D9AB48-3ABE-BD51-A97E-C9AEC34C1251}"/>
+              </a:ext>
+            </a:extLst>
+          </p:cNvPr>
           <p:cNvSpPr>
             <a:spLocks noGrp="1"/>
           </p:cNvSpPr>
@@ -7969,7 +7985,13 @@
       </p:sp>
       <p:sp>
         <p:nvSpPr>
-          <p:cNvPr id="3" name="Slide Number Placeholder 2"/>
+          <p:cNvPr id="3" name="Slide Number Placeholder 2">
+            <a:extLst>
+              <a:ext uri="{FF2B5EF4-FFF2-40B4-BE49-F238E27FC236}">
+                <a16:creationId xmlns:a16="http://schemas.microsoft.com/office/drawing/2014/main" id="{FCA36763-3B51-4EE5-65AD-368929F546E5}"/>
+              </a:ext>
+            </a:extLst>
+          </p:cNvPr>
           <p:cNvSpPr>
             <a:spLocks noGrp="1"/>
           </p:cNvSpPr>
@@ -7991,12 +8013,42 @@
           </a:p>
         </p:txBody>
       </p:sp>
+      <p:pic>
+        <p:nvPicPr>
+          <p:cNvPr id="5" name="Picture 4">
+            <a:extLst>
+              <a:ext uri="{FF2B5EF4-FFF2-40B4-BE49-F238E27FC236}">
+                <a16:creationId xmlns:a16="http://schemas.microsoft.com/office/drawing/2014/main" id="{AEA48795-EFED-06EB-2F4A-4CDFA03655E6}"/>
+              </a:ext>
+            </a:extLst>
+          </p:cNvPr>
+          <p:cNvPicPr>
+            <a:picLocks noChangeAspect="1"/>
+          </p:cNvPicPr>
+          <p:nvPr/>
+        </p:nvPicPr>
+        <p:blipFill>
+          <a:blip r:embed="rId2"/>
+          <a:stretch>
+            <a:fillRect/>
+          </a:stretch>
+        </p:blipFill>
+        <p:spPr>
+          <a:xfrm>
+            <a:off x="2635534" y="1280694"/>
+            <a:ext cx="7241696" cy="4688922"/>
+          </a:xfrm>
+          <a:prstGeom prst="rect">
+            <a:avLst/>
+          </a:prstGeom>
+        </p:spPr>
+      </p:pic>
       <p:sp>
         <p:nvSpPr>
-          <p:cNvPr id="4" name="TextBox 3">
+          <p:cNvPr id="6" name="TextBox 5">
             <a:extLst>
               <a:ext uri="{FF2B5EF4-FFF2-40B4-BE49-F238E27FC236}">
-                <a16:creationId xmlns:a16="http://schemas.microsoft.com/office/drawing/2014/main" id="{A2D65176-27C0-6A9C-1D22-589841C6C443}"/>
+                <a16:creationId xmlns:a16="http://schemas.microsoft.com/office/drawing/2014/main" id="{BAF9A8C0-47AC-8EB6-02CD-612ABF55FB5A}"/>
               </a:ext>
             </a:extLst>
           </p:cNvPr>
@@ -8005,8 +8057,8 @@
         </p:nvSpPr>
         <p:spPr>
           <a:xfrm>
-            <a:off x="2798445" y="182880"/>
-            <a:ext cx="6595110" cy="707886"/>
+            <a:off x="1992726" y="352547"/>
+            <a:ext cx="7492620" cy="707886"/>
           </a:xfrm>
           <a:prstGeom prst="rect">
             <a:avLst/>
@@ -8019,164 +8071,28 @@
           </a:bodyPr>
           <a:lstStyle/>
           <a:p>
-            <a:pPr algn="ctr"/>
+            <a:pPr algn="ctr">
+              <a:lnSpc>
+                <a:spcPct val="100000"/>
+              </a:lnSpc>
+              <a:spcBef>
+                <a:spcPts val="0"/>
+              </a:spcBef>
+            </a:pPr>
             <a:r>
               <a:rPr lang="en-US" sz="4000" b="1" dirty="0">
                 <a:latin typeface="Cambria" panose="02040503050406030204" pitchFamily="18" charset="0"/>
                 <a:ea typeface="Cambria" panose="02040503050406030204" pitchFamily="18" charset="0"/>
               </a:rPr>
-              <a:t>Conclusion</a:t>
-            </a:r>
-            <a:endParaRPr lang="en-IN" sz="4000" b="1" dirty="0">
-              <a:latin typeface="Cambria" panose="02040503050406030204" pitchFamily="18" charset="0"/>
-              <a:ea typeface="Cambria" panose="02040503050406030204" pitchFamily="18" charset="0"/>
-            </a:endParaRPr>
-          </a:p>
-        </p:txBody>
-      </p:sp>
-      <p:sp>
-        <p:nvSpPr>
-          <p:cNvPr id="5" name="TextBox 4">
-            <a:extLst>
-              <a:ext uri="{FF2B5EF4-FFF2-40B4-BE49-F238E27FC236}">
-                <a16:creationId xmlns:a16="http://schemas.microsoft.com/office/drawing/2014/main" id="{A71D121C-764E-8C3D-FB14-0491DCF40374}"/>
-              </a:ext>
-            </a:extLst>
-          </p:cNvPr>
-          <p:cNvSpPr txBox="1"/>
-          <p:nvPr/>
-        </p:nvSpPr>
-        <p:spPr>
-          <a:xfrm>
-            <a:off x="619760" y="1270000"/>
-            <a:ext cx="10088880" cy="3170099"/>
-          </a:xfrm>
-          <a:prstGeom prst="rect">
-            <a:avLst/>
-          </a:prstGeom>
-          <a:noFill/>
-        </p:spPr>
-        <p:txBody>
-          <a:bodyPr wrap="square" rtlCol="0">
-            <a:spAutoFit/>
-          </a:bodyPr>
-          <a:lstStyle/>
-          <a:p>
-            <a:pPr marL="285750" indent="-285750">
-              <a:lnSpc>
-                <a:spcPct val="150000"/>
-              </a:lnSpc>
-              <a:buFont typeface="Arial" panose="020B0604020202020204" pitchFamily="34" charset="0"/>
-              <a:buChar char="•"/>
-            </a:pPr>
-            <a:r>
-              <a:rPr lang="en-IN" sz="2000" dirty="0">
-                <a:latin typeface="Cambria" panose="02040503050406030204" pitchFamily="18" charset="0"/>
-                <a:ea typeface="Cambria" panose="02040503050406030204" pitchFamily="18" charset="0"/>
-              </a:rPr>
-              <a:t>The proposed </a:t>
-            </a:r>
-            <a:r>
-              <a:rPr lang="en-IN" sz="2000" b="1" dirty="0">
-                <a:latin typeface="Cambria" panose="02040503050406030204" pitchFamily="18" charset="0"/>
-                <a:ea typeface="Cambria" panose="02040503050406030204" pitchFamily="18" charset="0"/>
-              </a:rPr>
-              <a:t>Secure </a:t>
-            </a:r>
-            <a:r>
-              <a:rPr lang="en-IN" sz="2000" b="1" dirty="0" err="1">
-                <a:latin typeface="Cambria" panose="02040503050406030204" pitchFamily="18" charset="0"/>
-                <a:ea typeface="Cambria" panose="02040503050406030204" pitchFamily="18" charset="0"/>
-              </a:rPr>
-              <a:t>DevSecOps</a:t>
-            </a:r>
-            <a:r>
-              <a:rPr lang="en-IN" sz="2000" b="1" dirty="0">
-                <a:latin typeface="Cambria" panose="02040503050406030204" pitchFamily="18" charset="0"/>
-                <a:ea typeface="Cambria" panose="02040503050406030204" pitchFamily="18" charset="0"/>
-              </a:rPr>
-              <a:t> CI/CD pipeline</a:t>
-            </a:r>
-            <a:r>
-              <a:rPr lang="en-IN" sz="2000" dirty="0">
-                <a:latin typeface="Cambria" panose="02040503050406030204" pitchFamily="18" charset="0"/>
-                <a:ea typeface="Cambria" panose="02040503050406030204" pitchFamily="18" charset="0"/>
-              </a:rPr>
-              <a:t> integrates development, security testing, automated deployment, and monitoring into a single workflow.</a:t>
-            </a:r>
-          </a:p>
-          <a:p>
-            <a:pPr marL="285750" indent="-285750">
-              <a:lnSpc>
-                <a:spcPct val="150000"/>
-              </a:lnSpc>
-              <a:buFont typeface="Arial" panose="020B0604020202020204" pitchFamily="34" charset="0"/>
-              <a:buChar char="•"/>
-            </a:pPr>
-            <a:r>
-              <a:rPr lang="en-IN" sz="2000" dirty="0">
-                <a:latin typeface="Cambria" panose="02040503050406030204" pitchFamily="18" charset="0"/>
-                <a:ea typeface="Cambria" panose="02040503050406030204" pitchFamily="18" charset="0"/>
-              </a:rPr>
-              <a:t>By using tools like </a:t>
-            </a:r>
-            <a:r>
-              <a:rPr lang="en-IN" sz="2000" b="1" dirty="0">
-                <a:latin typeface="Cambria" panose="02040503050406030204" pitchFamily="18" charset="0"/>
-                <a:ea typeface="Cambria" panose="02040503050406030204" pitchFamily="18" charset="0"/>
-              </a:rPr>
-              <a:t>Jenkins, SonarQube, OWASP ZAP, Docker, and Kubernetes</a:t>
-            </a:r>
-            <a:r>
-              <a:rPr lang="en-IN" sz="2000" dirty="0">
-                <a:latin typeface="Cambria" panose="02040503050406030204" pitchFamily="18" charset="0"/>
-                <a:ea typeface="Cambria" panose="02040503050406030204" pitchFamily="18" charset="0"/>
-              </a:rPr>
-              <a:t>, the system improves software security, deployment speed, and reliability.</a:t>
-            </a:r>
-          </a:p>
-          <a:p>
-            <a:pPr marL="285750" indent="-285750">
-              <a:lnSpc>
-                <a:spcPct val="150000"/>
-              </a:lnSpc>
-              <a:buFont typeface="Arial" panose="020B0604020202020204" pitchFamily="34" charset="0"/>
-              <a:buChar char="•"/>
-            </a:pPr>
-            <a:r>
-              <a:rPr lang="en-IN" sz="2000" dirty="0">
-                <a:latin typeface="Cambria" panose="02040503050406030204" pitchFamily="18" charset="0"/>
-                <a:ea typeface="Cambria" panose="02040503050406030204" pitchFamily="18" charset="0"/>
-              </a:rPr>
-              <a:t>Continuous monitoring with </a:t>
-            </a:r>
-            <a:r>
-              <a:rPr lang="en-IN" sz="2000" b="1" dirty="0">
-                <a:latin typeface="Cambria" panose="02040503050406030204" pitchFamily="18" charset="0"/>
-                <a:ea typeface="Cambria" panose="02040503050406030204" pitchFamily="18" charset="0"/>
-              </a:rPr>
-              <a:t>Prometheus and Grafana</a:t>
-            </a:r>
-            <a:r>
-              <a:rPr lang="en-IN" sz="2000" dirty="0">
-                <a:latin typeface="Cambria" panose="02040503050406030204" pitchFamily="18" charset="0"/>
-                <a:ea typeface="Cambria" panose="02040503050406030204" pitchFamily="18" charset="0"/>
-              </a:rPr>
-              <a:t> ensures better performance, quick issue detection, and secure application delivery.</a:t>
-            </a:r>
-          </a:p>
-          <a:p>
-            <a:endParaRPr lang="en-IN" sz="2000" dirty="0">
-              <a:latin typeface="Cambria" panose="02040503050406030204" pitchFamily="18" charset="0"/>
-              <a:ea typeface="Cambria" panose="02040503050406030204" pitchFamily="18" charset="0"/>
-            </a:endParaRPr>
+              <a:t>Implementation</a:t>
+            </a:r>
           </a:p>
         </p:txBody>
       </p:sp>
     </p:spTree>
     <p:extLst>
       <p:ext uri="{BB962C8B-B14F-4D97-AF65-F5344CB8AC3E}">
-        <p14:creationId xmlns:p14="http://schemas.microsoft.com/office/powerpoint/2010/main" val="1212003767"/>
+        <p14:creationId xmlns:p14="http://schemas.microsoft.com/office/powerpoint/2010/main" val="3956735894"/>
       </p:ext>
     </p:extLst>
   </p:cSld>
@@ -8295,10 +8211,10 @@
       </p:sp>
       <p:sp>
         <p:nvSpPr>
-          <p:cNvPr id="5" name="Content Placeholder 7">
+          <p:cNvPr id="6" name="Content Placeholder 7">
             <a:extLst>
               <a:ext uri="{FF2B5EF4-FFF2-40B4-BE49-F238E27FC236}">
-                <a16:creationId xmlns:a16="http://schemas.microsoft.com/office/drawing/2014/main" id="{F745C16F-33D2-99EB-7E0E-85A0DC9ADD16}"/>
+                <a16:creationId xmlns:a16="http://schemas.microsoft.com/office/drawing/2014/main" id="{B62D77C7-8CCF-6D0D-A25B-E4D401ED93B0}"/>
               </a:ext>
             </a:extLst>
           </p:cNvPr>
@@ -8309,8 +8225,8 @@
         </p:nvSpPr>
         <p:spPr>
           <a:xfrm>
-            <a:off x="851846" y="1002233"/>
-            <a:ext cx="9438565" cy="5098316"/>
+            <a:off x="756311" y="890766"/>
+            <a:ext cx="8237377" cy="5387204"/>
           </a:xfrm>
           <a:prstGeom prst="rect">
             <a:avLst/>
@@ -8485,7 +8401,7 @@
           <a:p>
             <a:pPr>
               <a:lnSpc>
-                <a:spcPct val="150000"/>
+                <a:spcPts val="2600"/>
               </a:lnSpc>
               <a:spcBef>
                 <a:spcPts val="0"/>
@@ -8502,7 +8418,7 @@
           <a:p>
             <a:pPr>
               <a:lnSpc>
-                <a:spcPct val="150000"/>
+                <a:spcPts val="2600"/>
               </a:lnSpc>
               <a:spcBef>
                 <a:spcPts val="0"/>
@@ -8519,7 +8435,7 @@
           <a:p>
             <a:pPr>
               <a:lnSpc>
-                <a:spcPct val="150000"/>
+                <a:spcPts val="2600"/>
               </a:lnSpc>
               <a:spcBef>
                 <a:spcPts val="0"/>
@@ -8536,7 +8452,7 @@
           <a:p>
             <a:pPr>
               <a:lnSpc>
-                <a:spcPct val="150000"/>
+                <a:spcPts val="2600"/>
               </a:lnSpc>
               <a:spcBef>
                 <a:spcPts val="0"/>
@@ -8553,7 +8469,7 @@
           <a:p>
             <a:pPr>
               <a:lnSpc>
-                <a:spcPct val="150000"/>
+                <a:spcPts val="2600"/>
               </a:lnSpc>
               <a:spcBef>
                 <a:spcPts val="0"/>
@@ -8574,7 +8490,7 @@
           <a:p>
             <a:pPr>
               <a:lnSpc>
-                <a:spcPct val="150000"/>
+                <a:spcPts val="2600"/>
               </a:lnSpc>
               <a:spcBef>
                 <a:spcPts val="0"/>
@@ -8591,7 +8507,7 @@
           <a:p>
             <a:pPr>
               <a:lnSpc>
-                <a:spcPct val="150000"/>
+                <a:spcPts val="2600"/>
               </a:lnSpc>
               <a:spcBef>
                 <a:spcPts val="0"/>
@@ -8608,7 +8524,7 @@
           <a:p>
             <a:pPr>
               <a:lnSpc>
-                <a:spcPct val="150000"/>
+                <a:spcPts val="2600"/>
               </a:lnSpc>
               <a:spcBef>
                 <a:spcPts val="0"/>
@@ -8625,7 +8541,7 @@
           <a:p>
             <a:pPr>
               <a:lnSpc>
-                <a:spcPct val="150000"/>
+                <a:spcPts val="2600"/>
               </a:lnSpc>
               <a:spcBef>
                 <a:spcPts val="0"/>
@@ -8636,13 +8552,13 @@
                 <a:latin typeface="Cambria" panose="02040503050406030204" pitchFamily="18" charset="0"/>
                 <a:ea typeface="Cambria" panose="02040503050406030204" pitchFamily="18" charset="0"/>
               </a:rPr>
-              <a:t>Conclusion</a:t>
+              <a:t>Implementation</a:t>
             </a:r>
           </a:p>
           <a:p>
             <a:pPr>
               <a:lnSpc>
-                <a:spcPct val="150000"/>
+                <a:spcPts val="2600"/>
               </a:lnSpc>
               <a:spcBef>
                 <a:spcPts val="0"/>
@@ -8653,7 +8569,109 @@
                 <a:latin typeface="Cambria" panose="02040503050406030204" pitchFamily="18" charset="0"/>
                 <a:ea typeface="Cambria" panose="02040503050406030204" pitchFamily="18" charset="0"/>
               </a:rPr>
+              <a:t>Results</a:t>
+            </a:r>
+          </a:p>
+          <a:p>
+            <a:pPr>
+              <a:lnSpc>
+                <a:spcPts val="2600"/>
+              </a:lnSpc>
+              <a:spcBef>
+                <a:spcPts val="0"/>
+              </a:spcBef>
+            </a:pPr>
+            <a:r>
+              <a:rPr lang="en-US" sz="2200" dirty="0">
+                <a:latin typeface="Cambria" panose="02040503050406030204" pitchFamily="18" charset="0"/>
+                <a:ea typeface="Cambria" panose="02040503050406030204" pitchFamily="18" charset="0"/>
+              </a:rPr>
+              <a:t>Plagiarism report of Project Report and Conference Paper</a:t>
+            </a:r>
+          </a:p>
+          <a:p>
+            <a:pPr>
+              <a:lnSpc>
+                <a:spcPts val="2600"/>
+              </a:lnSpc>
+              <a:spcBef>
+                <a:spcPts val="0"/>
+              </a:spcBef>
+            </a:pPr>
+            <a:r>
+              <a:rPr lang="en-US" sz="2200" dirty="0">
+                <a:latin typeface="Cambria" panose="02040503050406030204" pitchFamily="18" charset="0"/>
+                <a:ea typeface="Cambria" panose="02040503050406030204" pitchFamily="18" charset="0"/>
+              </a:rPr>
+              <a:t>Proof of Submission </a:t>
+            </a:r>
+          </a:p>
+          <a:p>
+            <a:pPr>
+              <a:lnSpc>
+                <a:spcPts val="2600"/>
+              </a:lnSpc>
+              <a:spcBef>
+                <a:spcPts val="0"/>
+              </a:spcBef>
+            </a:pPr>
+            <a:r>
+              <a:rPr lang="en-US" sz="2200" dirty="0">
+                <a:latin typeface="Cambria" panose="02040503050406030204" pitchFamily="18" charset="0"/>
+                <a:ea typeface="Cambria" panose="02040503050406030204" pitchFamily="18" charset="0"/>
+              </a:rPr>
+              <a:t>Conclusion</a:t>
+            </a:r>
+          </a:p>
+          <a:p>
+            <a:pPr>
+              <a:lnSpc>
+                <a:spcPts val="2600"/>
+              </a:lnSpc>
+              <a:spcBef>
+                <a:spcPts val="0"/>
+              </a:spcBef>
+            </a:pPr>
+            <a:r>
+              <a:rPr lang="en-US" sz="2200" dirty="0">
+                <a:latin typeface="Cambria" panose="02040503050406030204" pitchFamily="18" charset="0"/>
+                <a:ea typeface="Cambria" panose="02040503050406030204" pitchFamily="18" charset="0"/>
+              </a:rPr>
               <a:t>References</a:t>
+            </a:r>
+          </a:p>
+          <a:p>
+            <a:pPr>
+              <a:lnSpc>
+                <a:spcPts val="2600"/>
+              </a:lnSpc>
+              <a:spcBef>
+                <a:spcPts val="0"/>
+              </a:spcBef>
+            </a:pPr>
+            <a:r>
+              <a:rPr lang="en-US" sz="2200" dirty="0">
+                <a:latin typeface="Cambria" panose="02040503050406030204" pitchFamily="18" charset="0"/>
+                <a:ea typeface="Cambria" panose="02040503050406030204" pitchFamily="18" charset="0"/>
+              </a:rPr>
+              <a:t>Plan of Action for Phase – II</a:t>
+            </a:r>
+          </a:p>
+          <a:p>
+            <a:pPr>
+              <a:lnSpc>
+                <a:spcPts val="2600"/>
+              </a:lnSpc>
+              <a:spcBef>
+                <a:spcPts val="0"/>
+              </a:spcBef>
+            </a:pPr>
+            <a:r>
+              <a:rPr lang="en-US" sz="2200" dirty="0">
+                <a:latin typeface="Cambria" panose="02040503050406030204" pitchFamily="18" charset="0"/>
+                <a:ea typeface="Cambria" panose="02040503050406030204" pitchFamily="18" charset="0"/>
+              </a:rPr>
+              <a:t>Time Line for Phase - II</a:t>
             </a:r>
           </a:p>
         </p:txBody>
@@ -8690,6 +8708,1757 @@
       </p:grpSpPr>
       <p:sp>
         <p:nvSpPr>
+          <p:cNvPr id="2" name="Footer Placeholder 1">
+            <a:extLst>
+              <a:ext uri="{FF2B5EF4-FFF2-40B4-BE49-F238E27FC236}">
+                <a16:creationId xmlns:a16="http://schemas.microsoft.com/office/drawing/2014/main" id="{1AFF1052-556E-DFC2-865D-0A99286941C2}"/>
+              </a:ext>
+            </a:extLst>
+          </p:cNvPr>
+          <p:cNvSpPr>
+            <a:spLocks noGrp="1"/>
+          </p:cNvSpPr>
+          <p:nvPr>
+            <p:ph type="ftr" sz="quarter" idx="3"/>
+          </p:nvPr>
+        </p:nvSpPr>
+        <p:spPr/>
+        <p:txBody>
+          <a:bodyPr/>
+          <a:lstStyle/>
+          <a:p>
+            <a:r>
+              <a:rPr lang="en-US"/>
+              <a:t>Dept. of CSE | GAT | 2025-26                                                                                                           CSEP23605</a:t>
+            </a:r>
+            <a:endParaRPr lang="en-IN" dirty="0"/>
+          </a:p>
+        </p:txBody>
+      </p:sp>
+      <p:sp>
+        <p:nvSpPr>
+          <p:cNvPr id="3" name="Slide Number Placeholder 2">
+            <a:extLst>
+              <a:ext uri="{FF2B5EF4-FFF2-40B4-BE49-F238E27FC236}">
+                <a16:creationId xmlns:a16="http://schemas.microsoft.com/office/drawing/2014/main" id="{03059B43-775E-AD30-E3F6-3FD7F00FEE16}"/>
+              </a:ext>
+            </a:extLst>
+          </p:cNvPr>
+          <p:cNvSpPr>
+            <a:spLocks noGrp="1"/>
+          </p:cNvSpPr>
+          <p:nvPr>
+            <p:ph type="sldNum" sz="quarter" idx="4"/>
+          </p:nvPr>
+        </p:nvSpPr>
+        <p:spPr/>
+        <p:txBody>
+          <a:bodyPr/>
+          <a:lstStyle/>
+          <a:p>
+            <a:fld id="{FFAE6D68-FB99-4243-9CC1-93FAA8C005BC}" type="slidenum">
+              <a:rPr lang="en-IN" smtClean="0"/>
+              <a:pPr/>
+              <a:t>20</a:t>
+            </a:fld>
+            <a:endParaRPr lang="en-IN"/>
+          </a:p>
+        </p:txBody>
+      </p:sp>
+      <p:sp>
+        <p:nvSpPr>
+          <p:cNvPr id="4" name="TextBox 3">
+            <a:extLst>
+              <a:ext uri="{FF2B5EF4-FFF2-40B4-BE49-F238E27FC236}">
+                <a16:creationId xmlns:a16="http://schemas.microsoft.com/office/drawing/2014/main" id="{5F0CBEFB-A337-8B5D-223D-0B706777DD33}"/>
+              </a:ext>
+            </a:extLst>
+          </p:cNvPr>
+          <p:cNvSpPr txBox="1"/>
+          <p:nvPr/>
+        </p:nvSpPr>
+        <p:spPr>
+          <a:xfrm>
+            <a:off x="2060814" y="272956"/>
+            <a:ext cx="7492620" cy="707886"/>
+          </a:xfrm>
+          <a:prstGeom prst="rect">
+            <a:avLst/>
+          </a:prstGeom>
+          <a:noFill/>
+        </p:spPr>
+        <p:txBody>
+          <a:bodyPr wrap="square" rtlCol="0">
+            <a:spAutoFit/>
+          </a:bodyPr>
+          <a:lstStyle/>
+          <a:p>
+            <a:pPr algn="ctr">
+              <a:lnSpc>
+                <a:spcPct val="100000"/>
+              </a:lnSpc>
+              <a:spcBef>
+                <a:spcPts val="0"/>
+              </a:spcBef>
+            </a:pPr>
+            <a:r>
+              <a:rPr lang="en-US" sz="4000" b="1" dirty="0">
+                <a:latin typeface="Cambria" panose="02040503050406030204" pitchFamily="18" charset="0"/>
+                <a:ea typeface="Cambria" panose="02040503050406030204" pitchFamily="18" charset="0"/>
+              </a:rPr>
+              <a:t>Results and Discussion</a:t>
+            </a:r>
+          </a:p>
+        </p:txBody>
+      </p:sp>
+      <p:pic>
+        <p:nvPicPr>
+          <p:cNvPr id="5" name="Picture 4">
+            <a:extLst>
+              <a:ext uri="{FF2B5EF4-FFF2-40B4-BE49-F238E27FC236}">
+                <a16:creationId xmlns:a16="http://schemas.microsoft.com/office/drawing/2014/main" id="{76420684-C746-9461-B909-CF9E138BBF47}"/>
+              </a:ext>
+            </a:extLst>
+          </p:cNvPr>
+          <p:cNvPicPr>
+            <a:picLocks noChangeAspect="1"/>
+          </p:cNvPicPr>
+          <p:nvPr/>
+        </p:nvPicPr>
+        <p:blipFill>
+          <a:blip r:embed="rId2"/>
+          <a:stretch>
+            <a:fillRect/>
+          </a:stretch>
+        </p:blipFill>
+        <p:spPr>
+          <a:xfrm>
+            <a:off x="1252853" y="1328621"/>
+            <a:ext cx="8926611" cy="4200758"/>
+          </a:xfrm>
+          <a:prstGeom prst="rect">
+            <a:avLst/>
+          </a:prstGeom>
+        </p:spPr>
+      </p:pic>
+      <p:pic>
+        <p:nvPicPr>
+          <p:cNvPr id="8" name="Picture 7">
+            <a:extLst>
+              <a:ext uri="{FF2B5EF4-FFF2-40B4-BE49-F238E27FC236}">
+                <a16:creationId xmlns:a16="http://schemas.microsoft.com/office/drawing/2014/main" id="{299C24CE-80D5-EB4F-C91C-AC4F6D0FA6D1}"/>
+              </a:ext>
+            </a:extLst>
+          </p:cNvPr>
+          <p:cNvPicPr>
+            <a:picLocks noChangeAspect="1"/>
+          </p:cNvPicPr>
+          <p:nvPr/>
+        </p:nvPicPr>
+        <p:blipFill>
+          <a:blip r:embed="rId3">
+            <a:extLst>
+              <a:ext uri="{28A0092B-C50C-407E-A947-70E740481C1C}">
+                <a14:useLocalDpi xmlns:a14="http://schemas.microsoft.com/office/drawing/2010/main" val="0"/>
+              </a:ext>
+            </a:extLst>
+          </a:blip>
+          <a:stretch>
+            <a:fillRect/>
+          </a:stretch>
+        </p:blipFill>
+        <p:spPr>
+          <a:xfrm>
+            <a:off x="1252852" y="1328621"/>
+            <a:ext cx="8926611" cy="4200758"/>
+          </a:xfrm>
+          <a:prstGeom prst="rect">
+            <a:avLst/>
+          </a:prstGeom>
+        </p:spPr>
+      </p:pic>
+      <p:pic>
+        <p:nvPicPr>
+          <p:cNvPr id="10" name="Picture 9">
+            <a:extLst>
+              <a:ext uri="{FF2B5EF4-FFF2-40B4-BE49-F238E27FC236}">
+                <a16:creationId xmlns:a16="http://schemas.microsoft.com/office/drawing/2014/main" id="{50E4DFEC-43D2-A13D-8367-2479D1D52240}"/>
+              </a:ext>
+            </a:extLst>
+          </p:cNvPr>
+          <p:cNvPicPr>
+            <a:picLocks noChangeAspect="1"/>
+          </p:cNvPicPr>
+          <p:nvPr/>
+        </p:nvPicPr>
+        <p:blipFill>
+          <a:blip r:embed="rId4">
+            <a:extLst>
+              <a:ext uri="{28A0092B-C50C-407E-A947-70E740481C1C}">
+                <a14:useLocalDpi xmlns:a14="http://schemas.microsoft.com/office/drawing/2010/main" val="0"/>
+              </a:ext>
+            </a:extLst>
+          </a:blip>
+          <a:stretch>
+            <a:fillRect/>
+          </a:stretch>
+        </p:blipFill>
+        <p:spPr>
+          <a:xfrm>
+            <a:off x="1252852" y="1410013"/>
+            <a:ext cx="8926611" cy="4119366"/>
+          </a:xfrm>
+          <a:prstGeom prst="rect">
+            <a:avLst/>
+          </a:prstGeom>
+        </p:spPr>
+      </p:pic>
+      <p:pic>
+        <p:nvPicPr>
+          <p:cNvPr id="12" name="Picture 11">
+            <a:extLst>
+              <a:ext uri="{FF2B5EF4-FFF2-40B4-BE49-F238E27FC236}">
+                <a16:creationId xmlns:a16="http://schemas.microsoft.com/office/drawing/2014/main" id="{0C550EFF-93B6-05D3-4E73-459CD74872A7}"/>
+              </a:ext>
+            </a:extLst>
+          </p:cNvPr>
+          <p:cNvPicPr>
+            <a:picLocks noChangeAspect="1"/>
+          </p:cNvPicPr>
+          <p:nvPr/>
+        </p:nvPicPr>
+        <p:blipFill>
+          <a:blip r:embed="rId5">
+            <a:extLst>
+              <a:ext uri="{28A0092B-C50C-407E-A947-70E740481C1C}">
+                <a14:useLocalDpi xmlns:a14="http://schemas.microsoft.com/office/drawing/2010/main" val="0"/>
+              </a:ext>
+            </a:extLst>
+          </a:blip>
+          <a:stretch>
+            <a:fillRect/>
+          </a:stretch>
+        </p:blipFill>
+        <p:spPr>
+          <a:xfrm>
+            <a:off x="1252851" y="1369317"/>
+            <a:ext cx="8848517" cy="4200758"/>
+          </a:xfrm>
+          <a:prstGeom prst="rect">
+            <a:avLst/>
+          </a:prstGeom>
+        </p:spPr>
+      </p:pic>
+    </p:spTree>
+    <p:extLst>
+      <p:ext uri="{BB962C8B-B14F-4D97-AF65-F5344CB8AC3E}">
+        <p14:creationId xmlns:p14="http://schemas.microsoft.com/office/powerpoint/2010/main" val="3655083812"/>
+      </p:ext>
+    </p:extLst>
+  </p:cSld>
+  <p:clrMapOvr>
+    <a:masterClrMapping/>
+  </p:clrMapOvr>
+  <p:timing>
+    <p:tnLst>
+      <p:par>
+        <p:cTn id="1" dur="indefinite" restart="never" nodeType="tmRoot">
+          <p:childTnLst>
+            <p:seq concurrent="1" nextAc="seek">
+              <p:cTn id="2" dur="indefinite" nodeType="mainSeq">
+                <p:childTnLst>
+                  <p:par>
+                    <p:cTn id="3" fill="hold">
+                      <p:stCondLst>
+                        <p:cond delay="indefinite"/>
+                      </p:stCondLst>
+                      <p:childTnLst>
+                        <p:par>
+                          <p:cTn id="4" fill="hold">
+                            <p:stCondLst>
+                              <p:cond delay="0"/>
+                            </p:stCondLst>
+                            <p:childTnLst>
+                              <p:par>
+                                <p:cTn id="5" presetID="10" presetClass="entr" presetSubtype="0" fill="hold" nodeType="clickEffect">
+                                  <p:stCondLst>
+                                    <p:cond delay="0"/>
+                                  </p:stCondLst>
+                                  <p:childTnLst>
+                                    <p:set>
+                                      <p:cBhvr>
+                                        <p:cTn id="6" dur="1" fill="hold">
+                                          <p:stCondLst>
+                                            <p:cond delay="0"/>
+                                          </p:stCondLst>
+                                        </p:cTn>
+                                        <p:tgtEl>
+                                          <p:spTgt spid="5"/>
+                                        </p:tgtEl>
+                                        <p:attrNameLst>
+                                          <p:attrName>style.visibility</p:attrName>
+                                        </p:attrNameLst>
+                                      </p:cBhvr>
+                                      <p:to>
+                                        <p:strVal val="visible"/>
+                                      </p:to>
+                                    </p:set>
+                                    <p:animEffect transition="in" filter="fade">
+                                      <p:cBhvr>
+                                        <p:cTn id="7" dur="500"/>
+                                        <p:tgtEl>
+                                          <p:spTgt spid="5"/>
+                                        </p:tgtEl>
+                                      </p:cBhvr>
+                                    </p:animEffect>
+                                  </p:childTnLst>
+                                </p:cTn>
+                              </p:par>
+                            </p:childTnLst>
+                          </p:cTn>
+                        </p:par>
+                      </p:childTnLst>
+                    </p:cTn>
+                  </p:par>
+                  <p:par>
+                    <p:cTn id="8" fill="hold">
+                      <p:stCondLst>
+                        <p:cond delay="indefinite"/>
+                      </p:stCondLst>
+                      <p:childTnLst>
+                        <p:par>
+                          <p:cTn id="9" fill="hold">
+                            <p:stCondLst>
+                              <p:cond delay="0"/>
+                            </p:stCondLst>
+                            <p:childTnLst>
+                              <p:par>
+                                <p:cTn id="10" presetID="2" presetClass="entr" presetSubtype="4" fill="hold" nodeType="clickEffect">
+                                  <p:stCondLst>
+                                    <p:cond delay="0"/>
+                                  </p:stCondLst>
+                                  <p:childTnLst>
+                                    <p:set>
+                                      <p:cBhvr>
+                                        <p:cTn id="11" dur="1" fill="hold">
+                                          <p:stCondLst>
+                                            <p:cond delay="0"/>
+                                          </p:stCondLst>
+                                        </p:cTn>
+                                        <p:tgtEl>
+                                          <p:spTgt spid="8"/>
+                                        </p:tgtEl>
+                                        <p:attrNameLst>
+                                          <p:attrName>style.visibility</p:attrName>
+                                        </p:attrNameLst>
+                                      </p:cBhvr>
+                                      <p:to>
+                                        <p:strVal val="visible"/>
+                                      </p:to>
+                                    </p:set>
+                                    <p:anim calcmode="lin" valueType="num">
+                                      <p:cBhvr additive="base">
+                                        <p:cTn id="12" dur="500" fill="hold"/>
+                                        <p:tgtEl>
+                                          <p:spTgt spid="8"/>
+                                        </p:tgtEl>
+                                        <p:attrNameLst>
+                                          <p:attrName>ppt_x</p:attrName>
+                                        </p:attrNameLst>
+                                      </p:cBhvr>
+                                      <p:tavLst>
+                                        <p:tav tm="0">
+                                          <p:val>
+                                            <p:strVal val="#ppt_x"/>
+                                          </p:val>
+                                        </p:tav>
+                                        <p:tav tm="100000">
+                                          <p:val>
+                                            <p:strVal val="#ppt_x"/>
+                                          </p:val>
+                                        </p:tav>
+                                      </p:tavLst>
+                                    </p:anim>
+                                    <p:anim calcmode="lin" valueType="num">
+                                      <p:cBhvr additive="base">
+                                        <p:cTn id="13" dur="500" fill="hold"/>
+                                        <p:tgtEl>
+                                          <p:spTgt spid="8"/>
+                                        </p:tgtEl>
+                                        <p:attrNameLst>
+                                          <p:attrName>ppt_y</p:attrName>
+                                        </p:attrNameLst>
+                                      </p:cBhvr>
+                                      <p:tavLst>
+                                        <p:tav tm="0">
+                                          <p:val>
+                                            <p:strVal val="1+#ppt_h/2"/>
+                                          </p:val>
+                                        </p:tav>
+                                        <p:tav tm="100000">
+                                          <p:val>
+                                            <p:strVal val="#ppt_y"/>
+                                          </p:val>
+                                        </p:tav>
+                                      </p:tavLst>
+                                    </p:anim>
+                                  </p:childTnLst>
+                                </p:cTn>
+                              </p:par>
+                            </p:childTnLst>
+                          </p:cTn>
+                        </p:par>
+                      </p:childTnLst>
+                    </p:cTn>
+                  </p:par>
+                  <p:par>
+                    <p:cTn id="14" fill="hold">
+                      <p:stCondLst>
+                        <p:cond delay="indefinite"/>
+                      </p:stCondLst>
+                      <p:childTnLst>
+                        <p:par>
+                          <p:cTn id="15" fill="hold">
+                            <p:stCondLst>
+                              <p:cond delay="0"/>
+                            </p:stCondLst>
+                            <p:childTnLst>
+                              <p:par>
+                                <p:cTn id="16" presetID="10" presetClass="entr" presetSubtype="0" fill="hold" nodeType="clickEffect">
+                                  <p:stCondLst>
+                                    <p:cond delay="0"/>
+                                  </p:stCondLst>
+                                  <p:childTnLst>
+                                    <p:set>
+                                      <p:cBhvr>
+                                        <p:cTn id="17" dur="1" fill="hold">
+                                          <p:stCondLst>
+                                            <p:cond delay="0"/>
+                                          </p:stCondLst>
+                                        </p:cTn>
+                                        <p:tgtEl>
+                                          <p:spTgt spid="10"/>
+                                        </p:tgtEl>
+                                        <p:attrNameLst>
+                                          <p:attrName>style.visibility</p:attrName>
+                                        </p:attrNameLst>
+                                      </p:cBhvr>
+                                      <p:to>
+                                        <p:strVal val="visible"/>
+                                      </p:to>
+                                    </p:set>
+                                    <p:animEffect transition="in" filter="fade">
+                                      <p:cBhvr>
+                                        <p:cTn id="18" dur="500"/>
+                                        <p:tgtEl>
+                                          <p:spTgt spid="10"/>
+                                        </p:tgtEl>
+                                      </p:cBhvr>
+                                    </p:animEffect>
+                                  </p:childTnLst>
+                                </p:cTn>
+                              </p:par>
+                            </p:childTnLst>
+                          </p:cTn>
+                        </p:par>
+                      </p:childTnLst>
+                    </p:cTn>
+                  </p:par>
+                  <p:par>
+                    <p:cTn id="19" fill="hold">
+                      <p:stCondLst>
+                        <p:cond delay="indefinite"/>
+                      </p:stCondLst>
+                      <p:childTnLst>
+                        <p:par>
+                          <p:cTn id="20" fill="hold">
+                            <p:stCondLst>
+                              <p:cond delay="0"/>
+                            </p:stCondLst>
+                            <p:childTnLst>
+                              <p:par>
+                                <p:cTn id="21" presetID="10" presetClass="entr" presetSubtype="0" fill="hold" nodeType="clickEffect">
+                                  <p:stCondLst>
+                                    <p:cond delay="0"/>
+                                  </p:stCondLst>
+                                  <p:childTnLst>
+                                    <p:set>
+                                      <p:cBhvr>
+                                        <p:cTn id="22" dur="1" fill="hold">
+                                          <p:stCondLst>
+                                            <p:cond delay="0"/>
+                                          </p:stCondLst>
+                                        </p:cTn>
+                                        <p:tgtEl>
+                                          <p:spTgt spid="12"/>
+                                        </p:tgtEl>
+                                        <p:attrNameLst>
+                                          <p:attrName>style.visibility</p:attrName>
+                                        </p:attrNameLst>
+                                      </p:cBhvr>
+                                      <p:to>
+                                        <p:strVal val="visible"/>
+                                      </p:to>
+                                    </p:set>
+                                    <p:animEffect transition="in" filter="fade">
+                                      <p:cBhvr>
+                                        <p:cTn id="23" dur="500"/>
+                                        <p:tgtEl>
+                                          <p:spTgt spid="12"/>
+                                        </p:tgtEl>
+                                      </p:cBhvr>
+                                    </p:animEffect>
+                                  </p:childTnLst>
+                                </p:cTn>
+                              </p:par>
+                            </p:childTnLst>
+                          </p:cTn>
+                        </p:par>
+                      </p:childTnLst>
+                    </p:cTn>
+                  </p:par>
+                </p:childTnLst>
+              </p:cTn>
+              <p:prevCondLst>
+                <p:cond evt="onPrev" delay="0">
+                  <p:tgtEl>
+                    <p:sldTgt/>
+                  </p:tgtEl>
+                </p:cond>
+              </p:prevCondLst>
+              <p:nextCondLst>
+                <p:cond evt="onNext" delay="0">
+                  <p:tgtEl>
+                    <p:sldTgt/>
+                  </p:tgtEl>
+                </p:cond>
+              </p:nextCondLst>
+            </p:seq>
+          </p:childTnLst>
+        </p:cTn>
+      </p:par>
+    </p:tnLst>
+  </p:timing>
+</p:sld>
+</file>
+
+<file path=ppt/slides/slide21.xml><?xml version="1.0" encoding="utf-8"?>
+<p:sld xmlns:a="http://schemas.openxmlformats.org/drawingml/2006/main" xmlns:r="http://schemas.openxmlformats.org/officeDocument/2006/relationships" xmlns:p="http://schemas.openxmlformats.org/presentationml/2006/main">
+  <p:cSld>
+    <p:spTree>
+      <p:nvGrpSpPr>
+        <p:cNvPr id="1" name="">
+          <a:extLst>
+            <a:ext uri="{FF2B5EF4-FFF2-40B4-BE49-F238E27FC236}">
+              <a16:creationId xmlns:a16="http://schemas.microsoft.com/office/drawing/2014/main" id="{E964CC05-D997-7B93-3618-4ED1E9C337C1}"/>
+            </a:ext>
+          </a:extLst>
+        </p:cNvPr>
+        <p:cNvGrpSpPr/>
+        <p:nvPr/>
+      </p:nvGrpSpPr>
+      <p:grpSpPr>
+        <a:xfrm>
+          <a:off x="0" y="0"/>
+          <a:ext cx="0" cy="0"/>
+          <a:chOff x="0" y="0"/>
+          <a:chExt cx="0" cy="0"/>
+        </a:xfrm>
+      </p:grpSpPr>
+      <p:sp>
+        <p:nvSpPr>
+          <p:cNvPr id="2" name="Footer Placeholder 1">
+            <a:extLst>
+              <a:ext uri="{FF2B5EF4-FFF2-40B4-BE49-F238E27FC236}">
+                <a16:creationId xmlns:a16="http://schemas.microsoft.com/office/drawing/2014/main" id="{79E427FB-7A6E-4698-35A3-7C6AD79A8380}"/>
+              </a:ext>
+            </a:extLst>
+          </p:cNvPr>
+          <p:cNvSpPr>
+            <a:spLocks noGrp="1"/>
+          </p:cNvSpPr>
+          <p:nvPr>
+            <p:ph type="ftr" sz="quarter" idx="3"/>
+          </p:nvPr>
+        </p:nvSpPr>
+        <p:spPr/>
+        <p:txBody>
+          <a:bodyPr/>
+          <a:lstStyle/>
+          <a:p>
+            <a:r>
+              <a:rPr lang="en-US"/>
+              <a:t>Dept. of CSE | GAT | 2025-26                                                                                                           CSEP23605</a:t>
+            </a:r>
+            <a:endParaRPr lang="en-IN" dirty="0"/>
+          </a:p>
+        </p:txBody>
+      </p:sp>
+      <p:sp>
+        <p:nvSpPr>
+          <p:cNvPr id="3" name="Slide Number Placeholder 2">
+            <a:extLst>
+              <a:ext uri="{FF2B5EF4-FFF2-40B4-BE49-F238E27FC236}">
+                <a16:creationId xmlns:a16="http://schemas.microsoft.com/office/drawing/2014/main" id="{53286DC9-2551-F166-6EFB-AE16BFA6AD47}"/>
+              </a:ext>
+            </a:extLst>
+          </p:cNvPr>
+          <p:cNvSpPr>
+            <a:spLocks noGrp="1"/>
+          </p:cNvSpPr>
+          <p:nvPr>
+            <p:ph type="sldNum" sz="quarter" idx="4"/>
+          </p:nvPr>
+        </p:nvSpPr>
+        <p:spPr/>
+        <p:txBody>
+          <a:bodyPr/>
+          <a:lstStyle/>
+          <a:p>
+            <a:fld id="{FFAE6D68-FB99-4243-9CC1-93FAA8C005BC}" type="slidenum">
+              <a:rPr lang="en-IN" smtClean="0"/>
+              <a:pPr/>
+              <a:t>21</a:t>
+            </a:fld>
+            <a:endParaRPr lang="en-IN"/>
+          </a:p>
+        </p:txBody>
+      </p:sp>
+      <p:sp>
+        <p:nvSpPr>
+          <p:cNvPr id="4" name="TextBox 3">
+            <a:extLst>
+              <a:ext uri="{FF2B5EF4-FFF2-40B4-BE49-F238E27FC236}">
+                <a16:creationId xmlns:a16="http://schemas.microsoft.com/office/drawing/2014/main" id="{9EA53157-1BD4-4A11-F7F4-9297149E9CD0}"/>
+              </a:ext>
+            </a:extLst>
+          </p:cNvPr>
+          <p:cNvSpPr txBox="1"/>
+          <p:nvPr/>
+        </p:nvSpPr>
+        <p:spPr>
+          <a:xfrm>
+            <a:off x="2798445" y="182880"/>
+            <a:ext cx="6595110" cy="707886"/>
+          </a:xfrm>
+          <a:prstGeom prst="rect">
+            <a:avLst/>
+          </a:prstGeom>
+          <a:noFill/>
+        </p:spPr>
+        <p:txBody>
+          <a:bodyPr wrap="square" rtlCol="0">
+            <a:spAutoFit/>
+          </a:bodyPr>
+          <a:lstStyle/>
+          <a:p>
+            <a:pPr>
+              <a:lnSpc>
+                <a:spcPct val="100000"/>
+              </a:lnSpc>
+              <a:spcBef>
+                <a:spcPts val="0"/>
+              </a:spcBef>
+            </a:pPr>
+            <a:r>
+              <a:rPr lang="en-US" sz="4000" b="1" dirty="0">
+                <a:latin typeface="Cambria" panose="02040503050406030204" pitchFamily="18" charset="0"/>
+                <a:ea typeface="Cambria" panose="02040503050406030204" pitchFamily="18" charset="0"/>
+              </a:rPr>
+              <a:t>Plan of Action for Phase – II</a:t>
+            </a:r>
+          </a:p>
+        </p:txBody>
+      </p:sp>
+      <p:sp>
+        <p:nvSpPr>
+          <p:cNvPr id="7" name="Rectangle 6">
+            <a:extLst>
+              <a:ext uri="{FF2B5EF4-FFF2-40B4-BE49-F238E27FC236}">
+                <a16:creationId xmlns:a16="http://schemas.microsoft.com/office/drawing/2014/main" id="{5C6CA400-083E-3DB3-6090-7AE97C4C526E}"/>
+              </a:ext>
+            </a:extLst>
+          </p:cNvPr>
+          <p:cNvSpPr/>
+          <p:nvPr/>
+        </p:nvSpPr>
+        <p:spPr>
+          <a:xfrm>
+            <a:off x="563880" y="982176"/>
+            <a:ext cx="11430000" cy="3785652"/>
+          </a:xfrm>
+          <a:prstGeom prst="rect">
+            <a:avLst/>
+          </a:prstGeom>
+        </p:spPr>
+        <p:txBody>
+          <a:bodyPr wrap="square">
+            <a:spAutoFit/>
+          </a:bodyPr>
+          <a:lstStyle/>
+          <a:p>
+            <a:endParaRPr lang="en-US" sz="2000" b="1" dirty="0">
+              <a:latin typeface="Cambria" panose="02040503050406030204" pitchFamily="18" charset="0"/>
+              <a:ea typeface="Cambria" panose="02040503050406030204" pitchFamily="18" charset="0"/>
+            </a:endParaRPr>
+          </a:p>
+          <a:p>
+            <a:pPr marL="342900" indent="-342900">
+              <a:buFont typeface="Arial" panose="020B0604020202020204" pitchFamily="34" charset="0"/>
+              <a:buChar char="•"/>
+            </a:pPr>
+            <a:r>
+              <a:rPr lang="en-US" sz="2000" dirty="0">
+                <a:latin typeface="Cambria" panose="02040503050406030204" pitchFamily="18" charset="0"/>
+                <a:ea typeface="Cambria" panose="02040503050406030204" pitchFamily="18" charset="0"/>
+              </a:rPr>
+              <a:t>Integrate advanced </a:t>
+            </a:r>
+            <a:r>
+              <a:rPr lang="en-US" sz="2000" dirty="0" err="1">
+                <a:latin typeface="Cambria" panose="02040503050406030204" pitchFamily="18" charset="0"/>
+                <a:ea typeface="Cambria" panose="02040503050406030204" pitchFamily="18" charset="0"/>
+              </a:rPr>
+              <a:t>DevSecOps</a:t>
+            </a:r>
+            <a:r>
+              <a:rPr lang="en-US" sz="2000" dirty="0">
+                <a:latin typeface="Cambria" panose="02040503050406030204" pitchFamily="18" charset="0"/>
+                <a:ea typeface="Cambria" panose="02040503050406030204" pitchFamily="18" charset="0"/>
+              </a:rPr>
+              <a:t> tools such as Jenkins, SonarQube, OWASP ZAP, Prometheus, and Grafana.</a:t>
+            </a:r>
+          </a:p>
+          <a:p>
+            <a:pPr marL="342900" indent="-342900">
+              <a:buFont typeface="Arial" panose="020B0604020202020204" pitchFamily="34" charset="0"/>
+              <a:buChar char="•"/>
+            </a:pPr>
+            <a:r>
+              <a:rPr lang="en-US" sz="2000" dirty="0">
+                <a:latin typeface="Cambria" panose="02040503050406030204" pitchFamily="18" charset="0"/>
+                <a:ea typeface="Cambria" panose="02040503050406030204" pitchFamily="18" charset="0"/>
+              </a:rPr>
+              <a:t>Automate CI/CD pipeline processes including build, testing, and deployment.</a:t>
+            </a:r>
+          </a:p>
+          <a:p>
+            <a:pPr marL="342900" indent="-342900">
+              <a:buFont typeface="Arial" panose="020B0604020202020204" pitchFamily="34" charset="0"/>
+              <a:buChar char="•"/>
+            </a:pPr>
+            <a:r>
+              <a:rPr lang="en-US" sz="2000" dirty="0">
+                <a:latin typeface="Cambria" panose="02040503050406030204" pitchFamily="18" charset="0"/>
+                <a:ea typeface="Cambria" panose="02040503050406030204" pitchFamily="18" charset="0"/>
+              </a:rPr>
+              <a:t>Implement Static Application Security Testing (SAST) and Dynamic Application Security Testing (DAST).</a:t>
+            </a:r>
+          </a:p>
+          <a:p>
+            <a:pPr marL="342900" indent="-342900">
+              <a:buFont typeface="Arial" panose="020B0604020202020204" pitchFamily="34" charset="0"/>
+              <a:buChar char="•"/>
+            </a:pPr>
+            <a:r>
+              <a:rPr lang="en-US" sz="2000" dirty="0">
+                <a:latin typeface="Cambria" panose="02040503050406030204" pitchFamily="18" charset="0"/>
+                <a:ea typeface="Cambria" panose="02040503050406030204" pitchFamily="18" charset="0"/>
+              </a:rPr>
+              <a:t>Add real-time monitoring, alert management, and performance analysis features.</a:t>
+            </a:r>
+          </a:p>
+          <a:p>
+            <a:pPr marL="342900" indent="-342900">
+              <a:buFont typeface="Arial" panose="020B0604020202020204" pitchFamily="34" charset="0"/>
+              <a:buChar char="•"/>
+            </a:pPr>
+            <a:r>
+              <a:rPr lang="en-US" sz="2000" dirty="0">
+                <a:latin typeface="Cambria" panose="02040503050406030204" pitchFamily="18" charset="0"/>
+                <a:ea typeface="Cambria" panose="02040503050406030204" pitchFamily="18" charset="0"/>
+              </a:rPr>
+              <a:t>Deploy the application on cloud platforms like AWS or Azure for better scalability.</a:t>
+            </a:r>
+          </a:p>
+          <a:p>
+            <a:pPr marL="342900" indent="-342900">
+              <a:buFont typeface="Arial" panose="020B0604020202020204" pitchFamily="34" charset="0"/>
+              <a:buChar char="•"/>
+            </a:pPr>
+            <a:r>
+              <a:rPr lang="en-US" sz="2000" dirty="0">
+                <a:latin typeface="Cambria" panose="02040503050406030204" pitchFamily="18" charset="0"/>
+                <a:ea typeface="Cambria" panose="02040503050406030204" pitchFamily="18" charset="0"/>
+              </a:rPr>
+              <a:t>Use Docker and Kubernetes for containerization and orchestration.</a:t>
+            </a:r>
+          </a:p>
+          <a:p>
+            <a:pPr marL="342900" indent="-342900">
+              <a:buFont typeface="Arial" panose="020B0604020202020204" pitchFamily="34" charset="0"/>
+              <a:buChar char="•"/>
+            </a:pPr>
+            <a:r>
+              <a:rPr lang="en-US" sz="2000" dirty="0">
+                <a:latin typeface="Cambria" panose="02040503050406030204" pitchFamily="18" charset="0"/>
+                <a:ea typeface="Cambria" panose="02040503050406030204" pitchFamily="18" charset="0"/>
+              </a:rPr>
+              <a:t>Enhance the system with AI-based threat detection and automated vulnerability analysis.</a:t>
+            </a:r>
+          </a:p>
+          <a:p>
+            <a:pPr marL="342900" indent="-342900">
+              <a:buFont typeface="Arial" panose="020B0604020202020204" pitchFamily="34" charset="0"/>
+              <a:buChar char="•"/>
+            </a:pPr>
+            <a:r>
+              <a:rPr lang="en-US" sz="2000" dirty="0">
+                <a:latin typeface="Cambria" panose="02040503050406030204" pitchFamily="18" charset="0"/>
+                <a:ea typeface="Cambria" panose="02040503050406030204" pitchFamily="18" charset="0"/>
+              </a:rPr>
+              <a:t>Improve overall automation, security, scalability, reliability, and continuous monitoring of the Secure DevOps pipeline.</a:t>
+            </a:r>
+          </a:p>
+        </p:txBody>
+      </p:sp>
+    </p:spTree>
+    <p:extLst>
+      <p:ext uri="{BB962C8B-B14F-4D97-AF65-F5344CB8AC3E}">
+        <p14:creationId xmlns:p14="http://schemas.microsoft.com/office/powerpoint/2010/main" val="2568296174"/>
+      </p:ext>
+    </p:extLst>
+  </p:cSld>
+  <p:clrMapOvr>
+    <a:masterClrMapping/>
+  </p:clrMapOvr>
+</p:sld>
+</file>
+
+<file path=ppt/slides/slide22.xml><?xml version="1.0" encoding="utf-8"?>
+<p:sld xmlns:a="http://schemas.openxmlformats.org/drawingml/2006/main" xmlns:r="http://schemas.openxmlformats.org/officeDocument/2006/relationships" xmlns:p="http://schemas.openxmlformats.org/presentationml/2006/main">
+  <p:cSld>
+    <p:spTree>
+      <p:nvGrpSpPr>
+        <p:cNvPr id="1" name="">
+          <a:extLst>
+            <a:ext uri="{FF2B5EF4-FFF2-40B4-BE49-F238E27FC236}">
+              <a16:creationId xmlns:a16="http://schemas.microsoft.com/office/drawing/2014/main" id="{C4E21454-74CD-6DDD-C73C-122031D86EF4}"/>
+            </a:ext>
+          </a:extLst>
+        </p:cNvPr>
+        <p:cNvGrpSpPr/>
+        <p:nvPr/>
+      </p:nvGrpSpPr>
+      <p:grpSpPr>
+        <a:xfrm>
+          <a:off x="0" y="0"/>
+          <a:ext cx="0" cy="0"/>
+          <a:chOff x="0" y="0"/>
+          <a:chExt cx="0" cy="0"/>
+        </a:xfrm>
+      </p:grpSpPr>
+      <p:sp>
+        <p:nvSpPr>
+          <p:cNvPr id="2" name="Footer Placeholder 1">
+            <a:extLst>
+              <a:ext uri="{FF2B5EF4-FFF2-40B4-BE49-F238E27FC236}">
+                <a16:creationId xmlns:a16="http://schemas.microsoft.com/office/drawing/2014/main" id="{B991078E-677E-04D3-34B0-6574706FB8BE}"/>
+              </a:ext>
+            </a:extLst>
+          </p:cNvPr>
+          <p:cNvSpPr>
+            <a:spLocks noGrp="1"/>
+          </p:cNvSpPr>
+          <p:nvPr>
+            <p:ph type="ftr" sz="quarter" idx="3"/>
+          </p:nvPr>
+        </p:nvSpPr>
+        <p:spPr/>
+        <p:txBody>
+          <a:bodyPr/>
+          <a:lstStyle/>
+          <a:p>
+            <a:r>
+              <a:rPr lang="en-US"/>
+              <a:t>Dept. of CSE | GAT | 2025-26                                                                                                           CSEP23605</a:t>
+            </a:r>
+            <a:endParaRPr lang="en-IN" dirty="0"/>
+          </a:p>
+        </p:txBody>
+      </p:sp>
+      <p:sp>
+        <p:nvSpPr>
+          <p:cNvPr id="3" name="Slide Number Placeholder 2">
+            <a:extLst>
+              <a:ext uri="{FF2B5EF4-FFF2-40B4-BE49-F238E27FC236}">
+                <a16:creationId xmlns:a16="http://schemas.microsoft.com/office/drawing/2014/main" id="{108BAB30-520D-0139-6B54-0C505C6FA432}"/>
+              </a:ext>
+            </a:extLst>
+          </p:cNvPr>
+          <p:cNvSpPr>
+            <a:spLocks noGrp="1"/>
+          </p:cNvSpPr>
+          <p:nvPr>
+            <p:ph type="sldNum" sz="quarter" idx="4"/>
+          </p:nvPr>
+        </p:nvSpPr>
+        <p:spPr/>
+        <p:txBody>
+          <a:bodyPr/>
+          <a:lstStyle/>
+          <a:p>
+            <a:fld id="{FFAE6D68-FB99-4243-9CC1-93FAA8C005BC}" type="slidenum">
+              <a:rPr lang="en-IN" smtClean="0"/>
+              <a:pPr/>
+              <a:t>22</a:t>
+            </a:fld>
+            <a:endParaRPr lang="en-IN"/>
+          </a:p>
+        </p:txBody>
+      </p:sp>
+      <p:sp>
+        <p:nvSpPr>
+          <p:cNvPr id="5" name="TextBox 4">
+            <a:extLst>
+              <a:ext uri="{FF2B5EF4-FFF2-40B4-BE49-F238E27FC236}">
+                <a16:creationId xmlns:a16="http://schemas.microsoft.com/office/drawing/2014/main" id="{83DC8A33-41CC-E66D-5806-A8B2007E6872}"/>
+              </a:ext>
+            </a:extLst>
+          </p:cNvPr>
+          <p:cNvSpPr txBox="1"/>
+          <p:nvPr/>
+        </p:nvSpPr>
+        <p:spPr>
+          <a:xfrm>
+            <a:off x="2798445" y="182880"/>
+            <a:ext cx="6595110" cy="707886"/>
+          </a:xfrm>
+          <a:prstGeom prst="rect">
+            <a:avLst/>
+          </a:prstGeom>
+          <a:noFill/>
+        </p:spPr>
+        <p:txBody>
+          <a:bodyPr wrap="square" rtlCol="0">
+            <a:spAutoFit/>
+          </a:bodyPr>
+          <a:lstStyle/>
+          <a:p>
+            <a:pPr algn="ctr">
+              <a:lnSpc>
+                <a:spcPct val="100000"/>
+              </a:lnSpc>
+              <a:spcBef>
+                <a:spcPts val="0"/>
+              </a:spcBef>
+            </a:pPr>
+            <a:r>
+              <a:rPr lang="en-US" sz="4000" b="1" dirty="0">
+                <a:latin typeface="Cambria" panose="02040503050406030204" pitchFamily="18" charset="0"/>
+                <a:ea typeface="Cambria" panose="02040503050406030204" pitchFamily="18" charset="0"/>
+              </a:rPr>
+              <a:t>Time Line for Phase - II</a:t>
+            </a:r>
+          </a:p>
+        </p:txBody>
+      </p:sp>
+      <p:graphicFrame>
+        <p:nvGraphicFramePr>
+          <p:cNvPr id="8" name="Table 7">
+            <a:extLst>
+              <a:ext uri="{FF2B5EF4-FFF2-40B4-BE49-F238E27FC236}">
+                <a16:creationId xmlns:a16="http://schemas.microsoft.com/office/drawing/2014/main" id="{0DDB0201-E0AA-F42D-3BD7-E1AC97E9E9AB}"/>
+              </a:ext>
+            </a:extLst>
+          </p:cNvPr>
+          <p:cNvGraphicFramePr>
+            <a:graphicFrameLocks noGrp="1"/>
+          </p:cNvGraphicFramePr>
+          <p:nvPr>
+            <p:extLst>
+              <p:ext uri="{D42A27DB-BD31-4B8C-83A1-F6EECF244321}">
+                <p14:modId xmlns:p14="http://schemas.microsoft.com/office/powerpoint/2010/main" val="2113649325"/>
+              </p:ext>
+            </p:extLst>
+          </p:nvPr>
+        </p:nvGraphicFramePr>
+        <p:xfrm>
+          <a:off x="106680" y="856972"/>
+          <a:ext cx="11978640" cy="5476192"/>
+        </p:xfrm>
+        <a:graphic>
+          <a:graphicData uri="http://schemas.openxmlformats.org/drawingml/2006/table">
+            <a:tbl>
+              <a:tblPr firstRow="1" bandRow="1">
+                <a:tableStyleId>{6E25E649-3F16-4E02-A733-19D2CDBF48F0}</a:tableStyleId>
+              </a:tblPr>
+              <a:tblGrid>
+                <a:gridCol w="3796206">
+                  <a:extLst>
+                    <a:ext uri="{9D8B030D-6E8A-4147-A177-3AD203B41FA5}">
+                      <a16:colId xmlns:a16="http://schemas.microsoft.com/office/drawing/2014/main" val="295784956"/>
+                    </a:ext>
+                  </a:extLst>
+                </a:gridCol>
+                <a:gridCol w="8182434">
+                  <a:extLst>
+                    <a:ext uri="{9D8B030D-6E8A-4147-A177-3AD203B41FA5}">
+                      <a16:colId xmlns:a16="http://schemas.microsoft.com/office/drawing/2014/main" val="1905354346"/>
+                    </a:ext>
+                  </a:extLst>
+                </a:gridCol>
+              </a:tblGrid>
+              <a:tr h="513672">
+                <a:tc>
+                  <a:txBody>
+                    <a:bodyPr/>
+                    <a:lstStyle/>
+                    <a:p>
+                      <a:r>
+                        <a:rPr lang="en-US" sz="2200" dirty="0">
+                          <a:latin typeface="Cambria" panose="02040503050406030204" pitchFamily="18" charset="0"/>
+                          <a:ea typeface="Cambria" panose="02040503050406030204" pitchFamily="18" charset="0"/>
+                        </a:rPr>
+                        <a:t>Week</a:t>
+                      </a:r>
+                      <a:endParaRPr lang="en-IN" sz="2200" dirty="0">
+                        <a:latin typeface="Cambria" panose="02040503050406030204" pitchFamily="18" charset="0"/>
+                        <a:ea typeface="Cambria" panose="02040503050406030204" pitchFamily="18" charset="0"/>
+                      </a:endParaRPr>
+                    </a:p>
+                  </a:txBody>
+                  <a:tcPr anchor="ctr"/>
+                </a:tc>
+                <a:tc>
+                  <a:txBody>
+                    <a:bodyPr/>
+                    <a:lstStyle/>
+                    <a:p>
+                      <a:r>
+                        <a:rPr lang="en-US" sz="2200" dirty="0">
+                          <a:latin typeface="Cambria" panose="02040503050406030204" pitchFamily="18" charset="0"/>
+                          <a:ea typeface="Cambria" panose="02040503050406030204" pitchFamily="18" charset="0"/>
+                        </a:rPr>
+                        <a:t>Description</a:t>
+                      </a:r>
+                      <a:endParaRPr lang="en-IN" sz="2200" dirty="0">
+                        <a:latin typeface="Cambria" panose="02040503050406030204" pitchFamily="18" charset="0"/>
+                        <a:ea typeface="Cambria" panose="02040503050406030204" pitchFamily="18" charset="0"/>
+                      </a:endParaRPr>
+                    </a:p>
+                  </a:txBody>
+                  <a:tcPr anchor="ctr"/>
+                </a:tc>
+                <a:extLst>
+                  <a:ext uri="{0D108BD9-81ED-4DB2-BD59-A6C34878D82A}">
+                    <a16:rowId xmlns:a16="http://schemas.microsoft.com/office/drawing/2014/main" val="3666978112"/>
+                  </a:ext>
+                </a:extLst>
+              </a:tr>
+              <a:tr h="513672">
+                <a:tc>
+                  <a:txBody>
+                    <a:bodyPr/>
+                    <a:lstStyle/>
+                    <a:p>
+                      <a:r>
+                        <a:rPr lang="en-US" sz="2200" dirty="0">
+                          <a:latin typeface="Cambria" panose="02040503050406030204" pitchFamily="18" charset="0"/>
+                          <a:ea typeface="Cambria" panose="02040503050406030204" pitchFamily="18" charset="0"/>
+                        </a:rPr>
+                        <a:t>July 2026:           Week 1</a:t>
+                      </a:r>
+                      <a:endParaRPr lang="en-IN" sz="2200" dirty="0">
+                        <a:latin typeface="Cambria" panose="02040503050406030204" pitchFamily="18" charset="0"/>
+                        <a:ea typeface="Cambria" panose="02040503050406030204" pitchFamily="18" charset="0"/>
+                      </a:endParaRPr>
+                    </a:p>
+                  </a:txBody>
+                  <a:tcPr anchor="ctr"/>
+                </a:tc>
+                <a:tc>
+                  <a:txBody>
+                    <a:bodyPr/>
+                    <a:lstStyle/>
+                    <a:p>
+                      <a:r>
+                        <a:rPr lang="en-IN" sz="2400" dirty="0"/>
+                        <a:t>Secure DevOps setup and CI/CD configuration</a:t>
+                      </a:r>
+                      <a:endParaRPr lang="en-IN" sz="2200" dirty="0">
+                        <a:latin typeface="Cambria" panose="02040503050406030204" pitchFamily="18" charset="0"/>
+                        <a:ea typeface="Cambria" panose="02040503050406030204" pitchFamily="18" charset="0"/>
+                      </a:endParaRPr>
+                    </a:p>
+                  </a:txBody>
+                  <a:tcPr anchor="ctr"/>
+                </a:tc>
+                <a:extLst>
+                  <a:ext uri="{0D108BD9-81ED-4DB2-BD59-A6C34878D82A}">
+                    <a16:rowId xmlns:a16="http://schemas.microsoft.com/office/drawing/2014/main" val="2183120440"/>
+                  </a:ext>
+                </a:extLst>
+              </a:tr>
+              <a:tr h="513672">
+                <a:tc>
+                  <a:txBody>
+                    <a:bodyPr/>
+                    <a:lstStyle/>
+                    <a:p>
+                      <a:pPr marL="0" marR="0" indent="0" algn="l" defTabSz="914400" rtl="0" eaLnBrk="1" fontAlgn="auto" latinLnBrk="0" hangingPunct="1">
+                        <a:lnSpc>
+                          <a:spcPct val="100000"/>
+                        </a:lnSpc>
+                        <a:spcBef>
+                          <a:spcPts val="0"/>
+                        </a:spcBef>
+                        <a:spcAft>
+                          <a:spcPts val="0"/>
+                        </a:spcAft>
+                        <a:buClrTx/>
+                        <a:buSzTx/>
+                        <a:buFontTx/>
+                        <a:buNone/>
+                        <a:tabLst/>
+                        <a:defRPr/>
+                      </a:pPr>
+                      <a:r>
+                        <a:rPr lang="en-US" sz="2200" dirty="0">
+                          <a:latin typeface="Cambria" panose="02040503050406030204" pitchFamily="18" charset="0"/>
+                          <a:ea typeface="Cambria" panose="02040503050406030204" pitchFamily="18" charset="0"/>
+                        </a:rPr>
+                        <a:t>July 2026:           Week 2</a:t>
+                      </a:r>
+                    </a:p>
+                  </a:txBody>
+                  <a:tcPr anchor="ctr"/>
+                </a:tc>
+                <a:tc>
+                  <a:txBody>
+                    <a:bodyPr/>
+                    <a:lstStyle/>
+                    <a:p>
+                      <a:pPr marL="0" marR="0" indent="0" algn="l" defTabSz="914400" rtl="0" eaLnBrk="1" fontAlgn="auto" latinLnBrk="0" hangingPunct="1">
+                        <a:lnSpc>
+                          <a:spcPct val="100000"/>
+                        </a:lnSpc>
+                        <a:spcBef>
+                          <a:spcPts val="0"/>
+                        </a:spcBef>
+                        <a:spcAft>
+                          <a:spcPts val="0"/>
+                        </a:spcAft>
+                        <a:buClrTx/>
+                        <a:buSzTx/>
+                        <a:buFontTx/>
+                        <a:buNone/>
+                        <a:tabLst/>
+                        <a:defRPr/>
+                      </a:pPr>
+                      <a:r>
+                        <a:rPr lang="en-US" sz="2400" dirty="0"/>
+                        <a:t>Integration of </a:t>
+                      </a:r>
+                      <a:r>
+                        <a:rPr lang="en-US" sz="2400" dirty="0" err="1"/>
+                        <a:t>DevSecOps</a:t>
+                      </a:r>
+                      <a:r>
+                        <a:rPr lang="en-US" sz="2400" dirty="0"/>
+                        <a:t> tools such as Jenkins, SonarQube, and OWASP ZAP</a:t>
+                      </a:r>
+                      <a:endParaRPr lang="en-IN" sz="2200" dirty="0">
+                        <a:latin typeface="Cambria" panose="02040503050406030204" pitchFamily="18" charset="0"/>
+                        <a:ea typeface="Cambria" panose="02040503050406030204" pitchFamily="18" charset="0"/>
+                      </a:endParaRPr>
+                    </a:p>
+                  </a:txBody>
+                  <a:tcPr anchor="ctr"/>
+                </a:tc>
+                <a:extLst>
+                  <a:ext uri="{0D108BD9-81ED-4DB2-BD59-A6C34878D82A}">
+                    <a16:rowId xmlns:a16="http://schemas.microsoft.com/office/drawing/2014/main" val="3536965470"/>
+                  </a:ext>
+                </a:extLst>
+              </a:tr>
+              <a:tr h="543856">
+                <a:tc>
+                  <a:txBody>
+                    <a:bodyPr/>
+                    <a:lstStyle/>
+                    <a:p>
+                      <a:pPr marL="0" marR="0" indent="0" algn="l" defTabSz="914400" rtl="0" eaLnBrk="1" fontAlgn="auto" latinLnBrk="0" hangingPunct="1">
+                        <a:lnSpc>
+                          <a:spcPct val="100000"/>
+                        </a:lnSpc>
+                        <a:spcBef>
+                          <a:spcPts val="0"/>
+                        </a:spcBef>
+                        <a:spcAft>
+                          <a:spcPts val="0"/>
+                        </a:spcAft>
+                        <a:buClrTx/>
+                        <a:buSzTx/>
+                        <a:buFontTx/>
+                        <a:buNone/>
+                        <a:tabLst/>
+                        <a:defRPr/>
+                      </a:pPr>
+                      <a:r>
+                        <a:rPr lang="en-US" sz="2200" dirty="0">
+                          <a:latin typeface="Cambria" panose="02040503050406030204" pitchFamily="18" charset="0"/>
+                          <a:ea typeface="Cambria" panose="02040503050406030204" pitchFamily="18" charset="0"/>
+                        </a:rPr>
+                        <a:t>July 2026:           Week 3</a:t>
+                      </a:r>
+                      <a:endParaRPr lang="en-IN" sz="2200" dirty="0">
+                        <a:latin typeface="Cambria" panose="02040503050406030204" pitchFamily="18" charset="0"/>
+                        <a:ea typeface="Cambria" panose="02040503050406030204" pitchFamily="18" charset="0"/>
+                      </a:endParaRPr>
+                    </a:p>
+                  </a:txBody>
+                  <a:tcPr anchor="ctr"/>
+                </a:tc>
+                <a:tc>
+                  <a:txBody>
+                    <a:bodyPr/>
+                    <a:lstStyle/>
+                    <a:p>
+                      <a:r>
+                        <a:rPr lang="en-US" sz="2400" dirty="0"/>
+                        <a:t>Automated security scanning and vulnerability testing</a:t>
+                      </a:r>
+                    </a:p>
+                  </a:txBody>
+                  <a:tcPr anchor="ctr"/>
+                </a:tc>
+                <a:extLst>
+                  <a:ext uri="{0D108BD9-81ED-4DB2-BD59-A6C34878D82A}">
+                    <a16:rowId xmlns:a16="http://schemas.microsoft.com/office/drawing/2014/main" val="2693487948"/>
+                  </a:ext>
+                </a:extLst>
+              </a:tr>
+              <a:tr h="513672">
+                <a:tc>
+                  <a:txBody>
+                    <a:bodyPr/>
+                    <a:lstStyle/>
+                    <a:p>
+                      <a:pPr marL="0" marR="0" indent="0" algn="l" defTabSz="914400" rtl="0" eaLnBrk="1" fontAlgn="auto" latinLnBrk="0" hangingPunct="1">
+                        <a:lnSpc>
+                          <a:spcPct val="100000"/>
+                        </a:lnSpc>
+                        <a:spcBef>
+                          <a:spcPts val="0"/>
+                        </a:spcBef>
+                        <a:spcAft>
+                          <a:spcPts val="0"/>
+                        </a:spcAft>
+                        <a:buClrTx/>
+                        <a:buSzTx/>
+                        <a:buFontTx/>
+                        <a:buNone/>
+                        <a:tabLst/>
+                        <a:defRPr/>
+                      </a:pPr>
+                      <a:r>
+                        <a:rPr lang="en-US" sz="2200" dirty="0">
+                          <a:latin typeface="Cambria" panose="02040503050406030204" pitchFamily="18" charset="0"/>
+                          <a:ea typeface="Cambria" panose="02040503050406030204" pitchFamily="18" charset="0"/>
+                        </a:rPr>
+                        <a:t>July 2026:           Week 4</a:t>
+                      </a:r>
+                      <a:endParaRPr lang="en-IN" sz="2200" dirty="0">
+                        <a:latin typeface="Cambria" panose="02040503050406030204" pitchFamily="18" charset="0"/>
+                        <a:ea typeface="Cambria" panose="02040503050406030204" pitchFamily="18" charset="0"/>
+                      </a:endParaRPr>
+                    </a:p>
+                  </a:txBody>
+                  <a:tcPr anchor="ctr"/>
+                </a:tc>
+                <a:tc>
+                  <a:txBody>
+                    <a:bodyPr/>
+                    <a:lstStyle/>
+                    <a:p>
+                      <a:r>
+                        <a:rPr lang="en-US" sz="2400" dirty="0"/>
+                        <a:t>Pipeline integration testing and validation</a:t>
+                      </a:r>
+                    </a:p>
+                  </a:txBody>
+                  <a:tcPr anchor="ctr"/>
+                </a:tc>
+                <a:extLst>
+                  <a:ext uri="{0D108BD9-81ED-4DB2-BD59-A6C34878D82A}">
+                    <a16:rowId xmlns:a16="http://schemas.microsoft.com/office/drawing/2014/main" val="278900492"/>
+                  </a:ext>
+                </a:extLst>
+              </a:tr>
+              <a:tr h="513672">
+                <a:tc>
+                  <a:txBody>
+                    <a:bodyPr/>
+                    <a:lstStyle/>
+                    <a:p>
+                      <a:pPr marL="0" marR="0" indent="0" algn="l" defTabSz="914400" rtl="0" eaLnBrk="1" fontAlgn="auto" latinLnBrk="0" hangingPunct="1">
+                        <a:lnSpc>
+                          <a:spcPct val="100000"/>
+                        </a:lnSpc>
+                        <a:spcBef>
+                          <a:spcPts val="0"/>
+                        </a:spcBef>
+                        <a:spcAft>
+                          <a:spcPts val="0"/>
+                        </a:spcAft>
+                        <a:buClrTx/>
+                        <a:buSzTx/>
+                        <a:buFontTx/>
+                        <a:buNone/>
+                        <a:tabLst/>
+                        <a:defRPr/>
+                      </a:pPr>
+                      <a:r>
+                        <a:rPr lang="en-US" sz="2200" dirty="0">
+                          <a:latin typeface="Cambria" panose="02040503050406030204" pitchFamily="18" charset="0"/>
+                          <a:ea typeface="Cambria" panose="02040503050406030204" pitchFamily="18" charset="0"/>
+                        </a:rPr>
+                        <a:t>August 2026:     Week</a:t>
+                      </a:r>
+                      <a:r>
+                        <a:rPr lang="en-US" sz="2200" baseline="0" dirty="0">
+                          <a:latin typeface="Cambria" panose="02040503050406030204" pitchFamily="18" charset="0"/>
+                          <a:ea typeface="Cambria" panose="02040503050406030204" pitchFamily="18" charset="0"/>
+                        </a:rPr>
+                        <a:t> </a:t>
+                      </a:r>
+                      <a:r>
+                        <a:rPr lang="en-IN" sz="2200" baseline="0" dirty="0">
+                          <a:latin typeface="Cambria" panose="02040503050406030204" pitchFamily="18" charset="0"/>
+                          <a:ea typeface="Cambria" panose="02040503050406030204" pitchFamily="18" charset="0"/>
+                        </a:rPr>
+                        <a:t>5</a:t>
+                      </a:r>
+                      <a:endParaRPr lang="en-IN" sz="2200" dirty="0">
+                        <a:latin typeface="Cambria" panose="02040503050406030204" pitchFamily="18" charset="0"/>
+                        <a:ea typeface="Cambria" panose="02040503050406030204" pitchFamily="18" charset="0"/>
+                      </a:endParaRPr>
+                    </a:p>
+                  </a:txBody>
+                  <a:tcPr anchor="ctr"/>
+                </a:tc>
+                <a:tc>
+                  <a:txBody>
+                    <a:bodyPr/>
+                    <a:lstStyle/>
+                    <a:p>
+                      <a:r>
+                        <a:rPr lang="en-US" sz="2400" dirty="0"/>
+                        <a:t>Performance monitoring setup using Prometheus and Grafana</a:t>
+                      </a:r>
+                      <a:endParaRPr lang="en-IN" sz="2200" dirty="0">
+                        <a:latin typeface="Cambria" panose="02040503050406030204" pitchFamily="18" charset="0"/>
+                        <a:ea typeface="Cambria" panose="02040503050406030204" pitchFamily="18" charset="0"/>
+                      </a:endParaRPr>
+                    </a:p>
+                  </a:txBody>
+                  <a:tcPr anchor="ctr"/>
+                </a:tc>
+                <a:extLst>
+                  <a:ext uri="{0D108BD9-81ED-4DB2-BD59-A6C34878D82A}">
+                    <a16:rowId xmlns:a16="http://schemas.microsoft.com/office/drawing/2014/main" val="29769606"/>
+                  </a:ext>
+                </a:extLst>
+              </a:tr>
+              <a:tr h="513672">
+                <a:tc>
+                  <a:txBody>
+                    <a:bodyPr/>
+                    <a:lstStyle/>
+                    <a:p>
+                      <a:pPr marL="0" marR="0" indent="0" algn="l" defTabSz="914400" rtl="0" eaLnBrk="1" fontAlgn="auto" latinLnBrk="0" hangingPunct="1">
+                        <a:lnSpc>
+                          <a:spcPct val="100000"/>
+                        </a:lnSpc>
+                        <a:spcBef>
+                          <a:spcPts val="0"/>
+                        </a:spcBef>
+                        <a:spcAft>
+                          <a:spcPts val="0"/>
+                        </a:spcAft>
+                        <a:buClrTx/>
+                        <a:buSzTx/>
+                        <a:buFontTx/>
+                        <a:buNone/>
+                        <a:tabLst/>
+                        <a:defRPr/>
+                      </a:pPr>
+                      <a:r>
+                        <a:rPr lang="en-US" sz="2200" dirty="0">
+                          <a:latin typeface="Cambria" panose="02040503050406030204" pitchFamily="18" charset="0"/>
+                          <a:ea typeface="Cambria" panose="02040503050406030204" pitchFamily="18" charset="0"/>
+                        </a:rPr>
+                        <a:t>August 2026:     Week</a:t>
+                      </a:r>
+                      <a:r>
+                        <a:rPr lang="en-US" sz="2200" baseline="0" dirty="0">
+                          <a:latin typeface="Cambria" panose="02040503050406030204" pitchFamily="18" charset="0"/>
+                          <a:ea typeface="Cambria" panose="02040503050406030204" pitchFamily="18" charset="0"/>
+                        </a:rPr>
+                        <a:t> </a:t>
+                      </a:r>
+                      <a:r>
+                        <a:rPr lang="en-IN" sz="2200" baseline="0" dirty="0">
+                          <a:latin typeface="Cambria" panose="02040503050406030204" pitchFamily="18" charset="0"/>
+                          <a:ea typeface="Cambria" panose="02040503050406030204" pitchFamily="18" charset="0"/>
+                        </a:rPr>
+                        <a:t>6</a:t>
+                      </a:r>
+                      <a:endParaRPr lang="en-IN" sz="2200" dirty="0">
+                        <a:latin typeface="Cambria" panose="02040503050406030204" pitchFamily="18" charset="0"/>
+                        <a:ea typeface="Cambria" panose="02040503050406030204" pitchFamily="18" charset="0"/>
+                      </a:endParaRPr>
+                    </a:p>
+                  </a:txBody>
+                  <a:tcPr anchor="ctr"/>
+                </a:tc>
+                <a:tc>
+                  <a:txBody>
+                    <a:bodyPr/>
+                    <a:lstStyle/>
+                    <a:p>
+                      <a:r>
+                        <a:rPr lang="en-US" sz="2200" dirty="0">
+                          <a:latin typeface="Cambria" panose="02040503050406030204" pitchFamily="18" charset="0"/>
+                          <a:ea typeface="Cambria" panose="02040503050406030204" pitchFamily="18" charset="0"/>
+                        </a:rPr>
+                        <a:t>Final documentation and report preparation</a:t>
+                      </a:r>
+                      <a:endParaRPr lang="en-IN" sz="2200" dirty="0">
+                        <a:latin typeface="Cambria" panose="02040503050406030204" pitchFamily="18" charset="0"/>
+                        <a:ea typeface="Cambria" panose="02040503050406030204" pitchFamily="18" charset="0"/>
+                      </a:endParaRPr>
+                    </a:p>
+                  </a:txBody>
+                  <a:tcPr anchor="ctr"/>
+                </a:tc>
+                <a:extLst>
+                  <a:ext uri="{0D108BD9-81ED-4DB2-BD59-A6C34878D82A}">
+                    <a16:rowId xmlns:a16="http://schemas.microsoft.com/office/drawing/2014/main" val="2341452696"/>
+                  </a:ext>
+                </a:extLst>
+              </a:tr>
+              <a:tr h="513672">
+                <a:tc>
+                  <a:txBody>
+                    <a:bodyPr/>
+                    <a:lstStyle/>
+                    <a:p>
+                      <a:r>
+                        <a:rPr lang="en-US" sz="2200" dirty="0">
+                          <a:latin typeface="Cambria" panose="02040503050406030204" pitchFamily="18" charset="0"/>
+                          <a:ea typeface="Cambria" panose="02040503050406030204" pitchFamily="18" charset="0"/>
+                        </a:rPr>
+                        <a:t>August 2026           …….</a:t>
+                      </a:r>
+                      <a:endParaRPr lang="en-IN" sz="2200" dirty="0">
+                        <a:latin typeface="Cambria" panose="02040503050406030204" pitchFamily="18" charset="0"/>
+                        <a:ea typeface="Cambria" panose="02040503050406030204" pitchFamily="18" charset="0"/>
+                      </a:endParaRPr>
+                    </a:p>
+                  </a:txBody>
+                  <a:tcPr anchor="ctr"/>
+                </a:tc>
+                <a:tc>
+                  <a:txBody>
+                    <a:bodyPr/>
+                    <a:lstStyle/>
+                    <a:p>
+                      <a:r>
+                        <a:rPr lang="en-US" sz="2200" dirty="0">
+                          <a:latin typeface="Cambria" panose="02040503050406030204" pitchFamily="18" charset="0"/>
+                          <a:ea typeface="Cambria" panose="02040503050406030204" pitchFamily="18" charset="0"/>
+                        </a:rPr>
+                        <a:t>Submission of manuscript to an Indexed Journal</a:t>
+                      </a:r>
+                      <a:endParaRPr lang="en-IN" sz="2200" dirty="0">
+                        <a:latin typeface="Cambria" panose="02040503050406030204" pitchFamily="18" charset="0"/>
+                        <a:ea typeface="Cambria" panose="02040503050406030204" pitchFamily="18" charset="0"/>
+                      </a:endParaRPr>
+                    </a:p>
+                  </a:txBody>
+                  <a:tcPr anchor="ctr"/>
+                </a:tc>
+                <a:extLst>
+                  <a:ext uri="{0D108BD9-81ED-4DB2-BD59-A6C34878D82A}">
+                    <a16:rowId xmlns:a16="http://schemas.microsoft.com/office/drawing/2014/main" val="1658074521"/>
+                  </a:ext>
+                </a:extLst>
+              </a:tr>
+              <a:tr h="513672">
+                <a:tc>
+                  <a:txBody>
+                    <a:bodyPr/>
+                    <a:lstStyle/>
+                    <a:p>
+                      <a:r>
+                        <a:rPr lang="en-US" sz="2200" dirty="0">
+                          <a:latin typeface="Cambria" panose="02040503050406030204" pitchFamily="18" charset="0"/>
+                          <a:ea typeface="Cambria" panose="02040503050406030204" pitchFamily="18" charset="0"/>
+                        </a:rPr>
+                        <a:t>September 2026    …….</a:t>
+                      </a:r>
+                      <a:endParaRPr lang="en-IN" sz="2200" dirty="0">
+                        <a:latin typeface="Cambria" panose="02040503050406030204" pitchFamily="18" charset="0"/>
+                        <a:ea typeface="Cambria" panose="02040503050406030204" pitchFamily="18" charset="0"/>
+                      </a:endParaRPr>
+                    </a:p>
+                  </a:txBody>
+                  <a:tcPr anchor="ctr"/>
+                </a:tc>
+                <a:tc>
+                  <a:txBody>
+                    <a:bodyPr/>
+                    <a:lstStyle/>
+                    <a:p>
+                      <a:r>
+                        <a:rPr lang="en-IN" sz="2200" kern="1200" dirty="0">
+                          <a:solidFill>
+                            <a:schemeClr val="dk1"/>
+                          </a:solidFill>
+                          <a:latin typeface="Cambria" panose="02040503050406030204" pitchFamily="18" charset="0"/>
+                          <a:ea typeface="Cambria" panose="02040503050406030204" pitchFamily="18" charset="0"/>
+                          <a:cs typeface="+mn-cs"/>
+                        </a:rPr>
+                        <a:t>Processing of submitted manuscript</a:t>
+                      </a:r>
+                    </a:p>
+                  </a:txBody>
+                  <a:tcPr anchor="ctr"/>
+                </a:tc>
+                <a:extLst>
+                  <a:ext uri="{0D108BD9-81ED-4DB2-BD59-A6C34878D82A}">
+                    <a16:rowId xmlns:a16="http://schemas.microsoft.com/office/drawing/2014/main" val="297968034"/>
+                  </a:ext>
+                </a:extLst>
+              </a:tr>
+              <a:tr h="513672">
+                <a:tc>
+                  <a:txBody>
+                    <a:bodyPr/>
+                    <a:lstStyle/>
+                    <a:p>
+                      <a:r>
+                        <a:rPr lang="en-US" sz="2200" dirty="0">
+                          <a:latin typeface="Cambria" panose="02040503050406030204" pitchFamily="18" charset="0"/>
+                          <a:ea typeface="Cambria" panose="02040503050406030204" pitchFamily="18" charset="0"/>
+                        </a:rPr>
+                        <a:t>October 2026          …….</a:t>
+                      </a:r>
+                      <a:endParaRPr lang="en-IN" sz="2200" dirty="0">
+                        <a:latin typeface="Cambria" panose="02040503050406030204" pitchFamily="18" charset="0"/>
+                        <a:ea typeface="Cambria" panose="02040503050406030204" pitchFamily="18" charset="0"/>
+                      </a:endParaRPr>
+                    </a:p>
+                  </a:txBody>
+                  <a:tcPr anchor="ctr"/>
+                </a:tc>
+                <a:tc>
+                  <a:txBody>
+                    <a:bodyPr/>
+                    <a:lstStyle/>
+                    <a:p>
+                      <a:r>
+                        <a:rPr lang="en-US" sz="2200" kern="1200" dirty="0">
+                          <a:solidFill>
+                            <a:schemeClr val="dk1"/>
+                          </a:solidFill>
+                          <a:latin typeface="Cambria" panose="02040503050406030204" pitchFamily="18" charset="0"/>
+                          <a:ea typeface="Cambria" panose="02040503050406030204" pitchFamily="18" charset="0"/>
+                          <a:cs typeface="+mn-cs"/>
+                        </a:rPr>
+                        <a:t>Journal review outcome and publication process completion</a:t>
+                      </a:r>
+                      <a:endParaRPr lang="en-IN" sz="2200" kern="1200" dirty="0">
+                        <a:solidFill>
+                          <a:schemeClr val="dk1"/>
+                        </a:solidFill>
+                        <a:latin typeface="Cambria" panose="02040503050406030204" pitchFamily="18" charset="0"/>
+                        <a:ea typeface="Cambria" panose="02040503050406030204" pitchFamily="18" charset="0"/>
+                        <a:cs typeface="+mn-cs"/>
+                      </a:endParaRPr>
+                    </a:p>
+                  </a:txBody>
+                  <a:tcPr anchor="ctr"/>
+                </a:tc>
+                <a:extLst>
+                  <a:ext uri="{0D108BD9-81ED-4DB2-BD59-A6C34878D82A}">
+                    <a16:rowId xmlns:a16="http://schemas.microsoft.com/office/drawing/2014/main" val="2824582192"/>
+                  </a:ext>
+                </a:extLst>
+              </a:tr>
+            </a:tbl>
+          </a:graphicData>
+        </a:graphic>
+      </p:graphicFrame>
+    </p:spTree>
+    <p:extLst>
+      <p:ext uri="{BB962C8B-B14F-4D97-AF65-F5344CB8AC3E}">
+        <p14:creationId xmlns:p14="http://schemas.microsoft.com/office/powerpoint/2010/main" val="2376091528"/>
+      </p:ext>
+    </p:extLst>
+  </p:cSld>
+  <p:clrMapOvr>
+    <a:masterClrMapping/>
+  </p:clrMapOvr>
+</p:sld>
+</file>
+
+<file path=ppt/slides/slide23.xml><?xml version="1.0" encoding="utf-8"?>
+<p:sld xmlns:a="http://schemas.openxmlformats.org/drawingml/2006/main" xmlns:r="http://schemas.openxmlformats.org/officeDocument/2006/relationships" xmlns:p="http://schemas.openxmlformats.org/presentationml/2006/main">
+  <p:cSld>
+    <p:spTree>
+      <p:nvGrpSpPr>
+        <p:cNvPr id="1" name="">
+          <a:extLst>
+            <a:ext uri="{FF2B5EF4-FFF2-40B4-BE49-F238E27FC236}">
+              <a16:creationId xmlns:a16="http://schemas.microsoft.com/office/drawing/2014/main" id="{678D4790-BCAA-3FB1-BAC4-4F4A81A55A68}"/>
+            </a:ext>
+          </a:extLst>
+        </p:cNvPr>
+        <p:cNvGrpSpPr/>
+        <p:nvPr/>
+      </p:nvGrpSpPr>
+      <p:grpSpPr>
+        <a:xfrm>
+          <a:off x="0" y="0"/>
+          <a:ext cx="0" cy="0"/>
+          <a:chOff x="0" y="0"/>
+          <a:chExt cx="0" cy="0"/>
+        </a:xfrm>
+      </p:grpSpPr>
+      <p:sp>
+        <p:nvSpPr>
+          <p:cNvPr id="2" name="Footer Placeholder 1">
+            <a:extLst>
+              <a:ext uri="{FF2B5EF4-FFF2-40B4-BE49-F238E27FC236}">
+                <a16:creationId xmlns:a16="http://schemas.microsoft.com/office/drawing/2014/main" id="{00C8552B-7890-2055-BF4B-9B38E154BE44}"/>
+              </a:ext>
+            </a:extLst>
+          </p:cNvPr>
+          <p:cNvSpPr>
+            <a:spLocks noGrp="1"/>
+          </p:cNvSpPr>
+          <p:nvPr>
+            <p:ph type="ftr" sz="quarter" idx="3"/>
+          </p:nvPr>
+        </p:nvSpPr>
+        <p:spPr/>
+        <p:txBody>
+          <a:bodyPr/>
+          <a:lstStyle/>
+          <a:p>
+            <a:r>
+              <a:rPr lang="en-US"/>
+              <a:t>Dept. of CSE | GAT | 2025-26                                                                                                           CSEP23605</a:t>
+            </a:r>
+            <a:endParaRPr lang="en-IN" dirty="0"/>
+          </a:p>
+        </p:txBody>
+      </p:sp>
+      <p:sp>
+        <p:nvSpPr>
+          <p:cNvPr id="3" name="Slide Number Placeholder 2">
+            <a:extLst>
+              <a:ext uri="{FF2B5EF4-FFF2-40B4-BE49-F238E27FC236}">
+                <a16:creationId xmlns:a16="http://schemas.microsoft.com/office/drawing/2014/main" id="{041839BF-FAD9-8298-F9A7-D3F21351F985}"/>
+              </a:ext>
+            </a:extLst>
+          </p:cNvPr>
+          <p:cNvSpPr>
+            <a:spLocks noGrp="1"/>
+          </p:cNvSpPr>
+          <p:nvPr>
+            <p:ph type="sldNum" sz="quarter" idx="4"/>
+          </p:nvPr>
+        </p:nvSpPr>
+        <p:spPr/>
+        <p:txBody>
+          <a:bodyPr/>
+          <a:lstStyle/>
+          <a:p>
+            <a:fld id="{FFAE6D68-FB99-4243-9CC1-93FAA8C005BC}" type="slidenum">
+              <a:rPr lang="en-IN" smtClean="0"/>
+              <a:pPr/>
+              <a:t>23</a:t>
+            </a:fld>
+            <a:endParaRPr lang="en-IN"/>
+          </a:p>
+        </p:txBody>
+      </p:sp>
+      <p:pic>
+        <p:nvPicPr>
+          <p:cNvPr id="6" name="Picture 5">
+            <a:extLst>
+              <a:ext uri="{FF2B5EF4-FFF2-40B4-BE49-F238E27FC236}">
+                <a16:creationId xmlns:a16="http://schemas.microsoft.com/office/drawing/2014/main" id="{55CF9B43-4F46-76BF-04AA-21F4A182D000}"/>
+              </a:ext>
+            </a:extLst>
+          </p:cNvPr>
+          <p:cNvPicPr>
+            <a:picLocks noChangeAspect="1"/>
+          </p:cNvPicPr>
+          <p:nvPr/>
+        </p:nvPicPr>
+        <p:blipFill>
+          <a:blip r:embed="rId2"/>
+          <a:stretch>
+            <a:fillRect/>
+          </a:stretch>
+        </p:blipFill>
+        <p:spPr>
+          <a:xfrm>
+            <a:off x="630556" y="792480"/>
+            <a:ext cx="10641555" cy="4480655"/>
+          </a:xfrm>
+          <a:prstGeom prst="rect">
+            <a:avLst/>
+          </a:prstGeom>
+        </p:spPr>
+      </p:pic>
+    </p:spTree>
+    <p:extLst>
+      <p:ext uri="{BB962C8B-B14F-4D97-AF65-F5344CB8AC3E}">
+        <p14:creationId xmlns:p14="http://schemas.microsoft.com/office/powerpoint/2010/main" val="3699362771"/>
+      </p:ext>
+    </p:extLst>
+  </p:cSld>
+  <p:clrMapOvr>
+    <a:masterClrMapping/>
+  </p:clrMapOvr>
+</p:sld>
+</file>
+
+<file path=ppt/slides/slide24.xml><?xml version="1.0" encoding="utf-8"?>
+<p:sld xmlns:a="http://schemas.openxmlformats.org/drawingml/2006/main" xmlns:r="http://schemas.openxmlformats.org/officeDocument/2006/relationships" xmlns:p="http://schemas.openxmlformats.org/presentationml/2006/main">
+  <p:cSld>
+    <p:spTree>
+      <p:nvGrpSpPr>
+        <p:cNvPr id="1" name=""/>
+        <p:cNvGrpSpPr/>
+        <p:nvPr/>
+      </p:nvGrpSpPr>
+      <p:grpSpPr>
+        <a:xfrm>
+          <a:off x="0" y="0"/>
+          <a:ext cx="0" cy="0"/>
+          <a:chOff x="0" y="0"/>
+          <a:chExt cx="0" cy="0"/>
+        </a:xfrm>
+      </p:grpSpPr>
+      <p:sp>
+        <p:nvSpPr>
           <p:cNvPr id="2" name="Footer Placeholder 1"/>
           <p:cNvSpPr>
             <a:spLocks noGrp="1"/>
@@ -8729,7 +10498,266 @@
             <a:fld id="{FFAE6D68-FB99-4243-9CC1-93FAA8C005BC}" type="slidenum">
               <a:rPr lang="en-IN" smtClean="0"/>
               <a:pPr/>
-              <a:t>20</a:t>
+              <a:t>24</a:t>
+            </a:fld>
+            <a:endParaRPr lang="en-IN"/>
+          </a:p>
+        </p:txBody>
+      </p:sp>
+      <p:sp>
+        <p:nvSpPr>
+          <p:cNvPr id="4" name="TextBox 3">
+            <a:extLst>
+              <a:ext uri="{FF2B5EF4-FFF2-40B4-BE49-F238E27FC236}">
+                <a16:creationId xmlns:a16="http://schemas.microsoft.com/office/drawing/2014/main" id="{A2D65176-27C0-6A9C-1D22-589841C6C443}"/>
+              </a:ext>
+            </a:extLst>
+          </p:cNvPr>
+          <p:cNvSpPr txBox="1"/>
+          <p:nvPr/>
+        </p:nvSpPr>
+        <p:spPr>
+          <a:xfrm>
+            <a:off x="2798445" y="182880"/>
+            <a:ext cx="6595110" cy="707886"/>
+          </a:xfrm>
+          <a:prstGeom prst="rect">
+            <a:avLst/>
+          </a:prstGeom>
+          <a:noFill/>
+        </p:spPr>
+        <p:txBody>
+          <a:bodyPr wrap="square" rtlCol="0">
+            <a:spAutoFit/>
+          </a:bodyPr>
+          <a:lstStyle/>
+          <a:p>
+            <a:pPr algn="ctr"/>
+            <a:r>
+              <a:rPr lang="en-US" sz="4000" b="1" dirty="0">
+                <a:latin typeface="Cambria" panose="02040503050406030204" pitchFamily="18" charset="0"/>
+                <a:ea typeface="Cambria" panose="02040503050406030204" pitchFamily="18" charset="0"/>
+              </a:rPr>
+              <a:t>Conclusion</a:t>
+            </a:r>
+            <a:endParaRPr lang="en-IN" sz="4000" b="1" dirty="0">
+              <a:latin typeface="Cambria" panose="02040503050406030204" pitchFamily="18" charset="0"/>
+              <a:ea typeface="Cambria" panose="02040503050406030204" pitchFamily="18" charset="0"/>
+            </a:endParaRPr>
+          </a:p>
+        </p:txBody>
+      </p:sp>
+      <p:sp>
+        <p:nvSpPr>
+          <p:cNvPr id="5" name="TextBox 4">
+            <a:extLst>
+              <a:ext uri="{FF2B5EF4-FFF2-40B4-BE49-F238E27FC236}">
+                <a16:creationId xmlns:a16="http://schemas.microsoft.com/office/drawing/2014/main" id="{A71D121C-764E-8C3D-FB14-0491DCF40374}"/>
+              </a:ext>
+            </a:extLst>
+          </p:cNvPr>
+          <p:cNvSpPr txBox="1"/>
+          <p:nvPr/>
+        </p:nvSpPr>
+        <p:spPr>
+          <a:xfrm>
+            <a:off x="619760" y="1270000"/>
+            <a:ext cx="10088880" cy="3170099"/>
+          </a:xfrm>
+          <a:prstGeom prst="rect">
+            <a:avLst/>
+          </a:prstGeom>
+          <a:noFill/>
+        </p:spPr>
+        <p:txBody>
+          <a:bodyPr wrap="square" rtlCol="0">
+            <a:spAutoFit/>
+          </a:bodyPr>
+          <a:lstStyle/>
+          <a:p>
+            <a:pPr marL="285750" indent="-285750">
+              <a:lnSpc>
+                <a:spcPct val="150000"/>
+              </a:lnSpc>
+              <a:buFont typeface="Arial" panose="020B0604020202020204" pitchFamily="34" charset="0"/>
+              <a:buChar char="•"/>
+            </a:pPr>
+            <a:r>
+              <a:rPr lang="en-IN" sz="2000" dirty="0">
+                <a:latin typeface="Cambria" panose="02040503050406030204" pitchFamily="18" charset="0"/>
+                <a:ea typeface="Cambria" panose="02040503050406030204" pitchFamily="18" charset="0"/>
+              </a:rPr>
+              <a:t>The proposed </a:t>
+            </a:r>
+            <a:r>
+              <a:rPr lang="en-IN" sz="2000" b="1" dirty="0">
+                <a:latin typeface="Cambria" panose="02040503050406030204" pitchFamily="18" charset="0"/>
+                <a:ea typeface="Cambria" panose="02040503050406030204" pitchFamily="18" charset="0"/>
+              </a:rPr>
+              <a:t>Secure </a:t>
+            </a:r>
+            <a:r>
+              <a:rPr lang="en-IN" sz="2000" b="1" dirty="0" err="1">
+                <a:latin typeface="Cambria" panose="02040503050406030204" pitchFamily="18" charset="0"/>
+                <a:ea typeface="Cambria" panose="02040503050406030204" pitchFamily="18" charset="0"/>
+              </a:rPr>
+              <a:t>DevSecOps</a:t>
+            </a:r>
+            <a:r>
+              <a:rPr lang="en-IN" sz="2000" b="1" dirty="0">
+                <a:latin typeface="Cambria" panose="02040503050406030204" pitchFamily="18" charset="0"/>
+                <a:ea typeface="Cambria" panose="02040503050406030204" pitchFamily="18" charset="0"/>
+              </a:rPr>
+              <a:t> CI/CD pipeline</a:t>
+            </a:r>
+            <a:r>
+              <a:rPr lang="en-IN" sz="2000" dirty="0">
+                <a:latin typeface="Cambria" panose="02040503050406030204" pitchFamily="18" charset="0"/>
+                <a:ea typeface="Cambria" panose="02040503050406030204" pitchFamily="18" charset="0"/>
+              </a:rPr>
+              <a:t> integrates development, security testing, automated deployment, and monitoring into a single workflow.</a:t>
+            </a:r>
+          </a:p>
+          <a:p>
+            <a:pPr marL="285750" indent="-285750">
+              <a:lnSpc>
+                <a:spcPct val="150000"/>
+              </a:lnSpc>
+              <a:buFont typeface="Arial" panose="020B0604020202020204" pitchFamily="34" charset="0"/>
+              <a:buChar char="•"/>
+            </a:pPr>
+            <a:r>
+              <a:rPr lang="en-IN" sz="2000" dirty="0">
+                <a:latin typeface="Cambria" panose="02040503050406030204" pitchFamily="18" charset="0"/>
+                <a:ea typeface="Cambria" panose="02040503050406030204" pitchFamily="18" charset="0"/>
+              </a:rPr>
+              <a:t>By using tools like </a:t>
+            </a:r>
+            <a:r>
+              <a:rPr lang="en-IN" sz="2000" b="1" dirty="0">
+                <a:latin typeface="Cambria" panose="02040503050406030204" pitchFamily="18" charset="0"/>
+                <a:ea typeface="Cambria" panose="02040503050406030204" pitchFamily="18" charset="0"/>
+              </a:rPr>
+              <a:t>Jenkins, SonarQube, OWASP ZAP, Docker, and Kubernetes</a:t>
+            </a:r>
+            <a:r>
+              <a:rPr lang="en-IN" sz="2000" dirty="0">
+                <a:latin typeface="Cambria" panose="02040503050406030204" pitchFamily="18" charset="0"/>
+                <a:ea typeface="Cambria" panose="02040503050406030204" pitchFamily="18" charset="0"/>
+              </a:rPr>
+              <a:t>, the system improves software security, deployment speed, and reliability.</a:t>
+            </a:r>
+          </a:p>
+          <a:p>
+            <a:pPr marL="285750" indent="-285750">
+              <a:lnSpc>
+                <a:spcPct val="150000"/>
+              </a:lnSpc>
+              <a:buFont typeface="Arial" panose="020B0604020202020204" pitchFamily="34" charset="0"/>
+              <a:buChar char="•"/>
+            </a:pPr>
+            <a:r>
+              <a:rPr lang="en-IN" sz="2000" dirty="0">
+                <a:latin typeface="Cambria" panose="02040503050406030204" pitchFamily="18" charset="0"/>
+                <a:ea typeface="Cambria" panose="02040503050406030204" pitchFamily="18" charset="0"/>
+              </a:rPr>
+              <a:t>Continuous monitoring with </a:t>
+            </a:r>
+            <a:r>
+              <a:rPr lang="en-IN" sz="2000" b="1" dirty="0">
+                <a:latin typeface="Cambria" panose="02040503050406030204" pitchFamily="18" charset="0"/>
+                <a:ea typeface="Cambria" panose="02040503050406030204" pitchFamily="18" charset="0"/>
+              </a:rPr>
+              <a:t>Prometheus and Grafana</a:t>
+            </a:r>
+            <a:r>
+              <a:rPr lang="en-IN" sz="2000" dirty="0">
+                <a:latin typeface="Cambria" panose="02040503050406030204" pitchFamily="18" charset="0"/>
+                <a:ea typeface="Cambria" panose="02040503050406030204" pitchFamily="18" charset="0"/>
+              </a:rPr>
+              <a:t> ensures better performance, quick issue detection, and secure application delivery.</a:t>
+            </a:r>
+          </a:p>
+          <a:p>
+            <a:endParaRPr lang="en-IN" sz="2000" dirty="0">
+              <a:latin typeface="Cambria" panose="02040503050406030204" pitchFamily="18" charset="0"/>
+              <a:ea typeface="Cambria" panose="02040503050406030204" pitchFamily="18" charset="0"/>
+            </a:endParaRPr>
+          </a:p>
+        </p:txBody>
+      </p:sp>
+    </p:spTree>
+    <p:extLst>
+      <p:ext uri="{BB962C8B-B14F-4D97-AF65-F5344CB8AC3E}">
+        <p14:creationId xmlns:p14="http://schemas.microsoft.com/office/powerpoint/2010/main" val="1212003767"/>
+      </p:ext>
+    </p:extLst>
+  </p:cSld>
+  <p:clrMapOvr>
+    <a:masterClrMapping/>
+  </p:clrMapOvr>
+</p:sld>
+</file>
+
+<file path=ppt/slides/slide25.xml><?xml version="1.0" encoding="utf-8"?>
+<p:sld xmlns:a="http://schemas.openxmlformats.org/drawingml/2006/main" xmlns:r="http://schemas.openxmlformats.org/officeDocument/2006/relationships" xmlns:p="http://schemas.openxmlformats.org/presentationml/2006/main">
+  <p:cSld>
+    <p:spTree>
+      <p:nvGrpSpPr>
+        <p:cNvPr id="1" name=""/>
+        <p:cNvGrpSpPr/>
+        <p:nvPr/>
+      </p:nvGrpSpPr>
+      <p:grpSpPr>
+        <a:xfrm>
+          <a:off x="0" y="0"/>
+          <a:ext cx="0" cy="0"/>
+          <a:chOff x="0" y="0"/>
+          <a:chExt cx="0" cy="0"/>
+        </a:xfrm>
+      </p:grpSpPr>
+      <p:sp>
+        <p:nvSpPr>
+          <p:cNvPr id="2" name="Footer Placeholder 1"/>
+          <p:cNvSpPr>
+            <a:spLocks noGrp="1"/>
+          </p:cNvSpPr>
+          <p:nvPr>
+            <p:ph type="ftr" sz="quarter" idx="3"/>
+          </p:nvPr>
+        </p:nvSpPr>
+        <p:spPr/>
+        <p:txBody>
+          <a:bodyPr/>
+          <a:lstStyle/>
+          <a:p>
+            <a:r>
+              <a:rPr lang="en-US"/>
+              <a:t>Dept. of CSE | GAT | 2025-26                                                                                                           CSEP23605</a:t>
+            </a:r>
+            <a:endParaRPr lang="en-IN" dirty="0"/>
+          </a:p>
+        </p:txBody>
+      </p:sp>
+      <p:sp>
+        <p:nvSpPr>
+          <p:cNvPr id="3" name="Slide Number Placeholder 2"/>
+          <p:cNvSpPr>
+            <a:spLocks noGrp="1"/>
+          </p:cNvSpPr>
+          <p:nvPr>
+            <p:ph type="sldNum" sz="quarter" idx="4"/>
+          </p:nvPr>
+        </p:nvSpPr>
+        <p:spPr/>
+        <p:txBody>
+          <a:bodyPr/>
+          <a:lstStyle/>
+          <a:p>
+            <a:fld id="{FFAE6D68-FB99-4243-9CC1-93FAA8C005BC}" type="slidenum">
+              <a:rPr lang="en-IN" smtClean="0"/>
+              <a:pPr/>
+              <a:t>25</a:t>
             </a:fld>
             <a:endParaRPr lang="en-IN"/>
           </a:p>
@@ -9069,7 +11097,7 @@
 </p:sld>
 </file>
 
-<file path=ppt/slides/slide21.xml><?xml version="1.0" encoding="utf-8"?>
+<file path=ppt/slides/slide26.xml><?xml version="1.0" encoding="utf-8"?>
 <p:sld xmlns:a="http://schemas.openxmlformats.org/drawingml/2006/main" xmlns:r="http://schemas.openxmlformats.org/officeDocument/2006/relationships" xmlns:p="http://schemas.openxmlformats.org/presentationml/2006/main">
   <p:cSld>
     <p:spTree>
@@ -9145,7 +11173,7 @@
             <a:fld id="{FFAE6D68-FB99-4243-9CC1-93FAA8C005BC}" type="slidenum">
               <a:rPr lang="en-IN" smtClean="0"/>
               <a:pPr/>
-              <a:t>21</a:t>
+              <a:t>26</a:t>
             </a:fld>
             <a:endParaRPr lang="en-IN"/>
           </a:p>
@@ -9492,7 +11520,7 @@
 </p:sld>
 </file>
 
-<file path=ppt/slides/slide22.xml><?xml version="1.0" encoding="utf-8"?>
+<file path=ppt/slides/slide27.xml><?xml version="1.0" encoding="utf-8"?>
 <p:sld xmlns:a="http://schemas.openxmlformats.org/drawingml/2006/main" xmlns:r="http://schemas.openxmlformats.org/officeDocument/2006/relationships" xmlns:p="http://schemas.openxmlformats.org/presentationml/2006/main">
   <p:cSld>
     <p:spTree>
@@ -9568,7 +11596,7 @@
             <a:fld id="{FFAE6D68-FB99-4243-9CC1-93FAA8C005BC}" type="slidenum">
               <a:rPr lang="en-IN" smtClean="0"/>
               <a:pPr/>
-              <a:t>22</a:t>
+              <a:t>27</a:t>
             </a:fld>
             <a:endParaRPr lang="en-IN"/>
           </a:p>
@@ -9919,7 +11947,7 @@
 </p:sld>
 </file>
 
-<file path=ppt/slides/slide23.xml><?xml version="1.0" encoding="utf-8"?>
+<file path=ppt/slides/slide28.xml><?xml version="1.0" encoding="utf-8"?>
 <p:sld xmlns:a="http://schemas.openxmlformats.org/drawingml/2006/main" xmlns:r="http://schemas.openxmlformats.org/officeDocument/2006/relationships" xmlns:p="http://schemas.openxmlformats.org/presentationml/2006/main">
   <p:cSld>
     <p:spTree>
@@ -9995,7 +12023,7 @@
             <a:fld id="{FFAE6D68-FB99-4243-9CC1-93FAA8C005BC}" type="slidenum">
               <a:rPr lang="en-IN" smtClean="0"/>
               <a:pPr/>
-              <a:t>23</a:t>
+              <a:t>28</a:t>
             </a:fld>
             <a:endParaRPr lang="en-IN"/>
           </a:p>
@@ -10282,7 +12310,7 @@
 </p:sld>
 </file>
 
-<file path=ppt/slides/slide24.xml><?xml version="1.0" encoding="utf-8"?>
+<file path=ppt/slides/slide29.xml><?xml version="1.0" encoding="utf-8"?>
 <p:sld xmlns:a="http://schemas.openxmlformats.org/drawingml/2006/main" xmlns:r="http://schemas.openxmlformats.org/officeDocument/2006/relationships" xmlns:p="http://schemas.openxmlformats.org/presentationml/2006/main">
   <p:cSld>
     <p:spTree>
@@ -10358,7 +12386,7 @@
             <a:fld id="{FFAE6D68-FB99-4243-9CC1-93FAA8C005BC}" type="slidenum">
               <a:rPr lang="en-IN" smtClean="0"/>
               <a:pPr/>
-              <a:t>24</a:t>
+              <a:t>29</a:t>
             </a:fld>
             <a:endParaRPr lang="en-IN"/>
           </a:p>
@@ -10668,246 +12696,6 @@
     <p:extLst>
       <p:ext uri="{BB962C8B-B14F-4D97-AF65-F5344CB8AC3E}">
         <p14:creationId xmlns:p14="http://schemas.microsoft.com/office/powerpoint/2010/main" val="3723000208"/>
-      </p:ext>
-    </p:extLst>
-  </p:cSld>
-  <p:clrMapOvr>
-    <a:masterClrMapping/>
-  </p:clrMapOvr>
-</p:sld>
-</file>
-
-<file path=ppt/slides/slide25.xml><?xml version="1.0" encoding="utf-8"?>
-<p:sld xmlns:a="http://schemas.openxmlformats.org/drawingml/2006/main" xmlns:r="http://schemas.openxmlformats.org/officeDocument/2006/relationships" xmlns:p="http://schemas.openxmlformats.org/presentationml/2006/main">
-  <p:cSld>
-    <p:spTree>
-      <p:nvGrpSpPr>
-        <p:cNvPr id="1" name=""/>
-        <p:cNvGrpSpPr/>
-        <p:nvPr/>
-      </p:nvGrpSpPr>
-      <p:grpSpPr>
-        <a:xfrm>
-          <a:off x="0" y="0"/>
-          <a:ext cx="0" cy="0"/>
-          <a:chOff x="0" y="0"/>
-          <a:chExt cx="0" cy="0"/>
-        </a:xfrm>
-      </p:grpSpPr>
-      <p:sp>
-        <p:nvSpPr>
-          <p:cNvPr id="2" name="Footer Placeholder 1"/>
-          <p:cNvSpPr>
-            <a:spLocks noGrp="1"/>
-          </p:cNvSpPr>
-          <p:nvPr>
-            <p:ph type="ftr" sz="quarter" idx="3"/>
-          </p:nvPr>
-        </p:nvSpPr>
-        <p:spPr/>
-        <p:txBody>
-          <a:bodyPr/>
-          <a:lstStyle/>
-          <a:p>
-            <a:r>
-              <a:rPr lang="en-US"/>
-              <a:t>Dept. of CSE | GAT | 2025-26                                                                                                           CSEP23605</a:t>
-            </a:r>
-            <a:endParaRPr lang="en-IN" dirty="0"/>
-          </a:p>
-        </p:txBody>
-      </p:sp>
-      <p:sp>
-        <p:nvSpPr>
-          <p:cNvPr id="3" name="Slide Number Placeholder 2"/>
-          <p:cNvSpPr>
-            <a:spLocks noGrp="1"/>
-          </p:cNvSpPr>
-          <p:nvPr>
-            <p:ph type="sldNum" sz="quarter" idx="4"/>
-          </p:nvPr>
-        </p:nvSpPr>
-        <p:spPr/>
-        <p:txBody>
-          <a:bodyPr/>
-          <a:lstStyle/>
-          <a:p>
-            <a:fld id="{FFAE6D68-FB99-4243-9CC1-93FAA8C005BC}" type="slidenum">
-              <a:rPr lang="en-IN" smtClean="0"/>
-              <a:pPr/>
-              <a:t>25</a:t>
-            </a:fld>
-            <a:endParaRPr lang="en-IN"/>
-          </a:p>
-        </p:txBody>
-      </p:sp>
-      <p:sp>
-        <p:nvSpPr>
-          <p:cNvPr id="4" name="TextBox 3">
-            <a:extLst>
-              <a:ext uri="{FF2B5EF4-FFF2-40B4-BE49-F238E27FC236}">
-                <a16:creationId xmlns:a16="http://schemas.microsoft.com/office/drawing/2014/main" id="{A2D65176-27C0-6A9C-1D22-589841C6C443}"/>
-              </a:ext>
-            </a:extLst>
-          </p:cNvPr>
-          <p:cNvSpPr txBox="1"/>
-          <p:nvPr/>
-        </p:nvSpPr>
-        <p:spPr>
-          <a:xfrm>
-            <a:off x="2730389" y="2775955"/>
-            <a:ext cx="6595110" cy="707886"/>
-          </a:xfrm>
-          <a:prstGeom prst="rect">
-            <a:avLst/>
-          </a:prstGeom>
-          <a:noFill/>
-        </p:spPr>
-        <p:txBody>
-          <a:bodyPr wrap="square" rtlCol="0">
-            <a:spAutoFit/>
-          </a:bodyPr>
-          <a:lstStyle/>
-          <a:p>
-            <a:pPr algn="ctr"/>
-            <a:r>
-              <a:rPr lang="en-US" sz="4000" b="1" dirty="0">
-                <a:latin typeface="Cambria" panose="02040503050406030204" pitchFamily="18" charset="0"/>
-                <a:ea typeface="Cambria" panose="02040503050406030204" pitchFamily="18" charset="0"/>
-              </a:rPr>
-              <a:t>Q &amp; A</a:t>
-            </a:r>
-            <a:endParaRPr lang="en-IN" sz="4000" b="1" dirty="0">
-              <a:latin typeface="Cambria" panose="02040503050406030204" pitchFamily="18" charset="0"/>
-              <a:ea typeface="Cambria" panose="02040503050406030204" pitchFamily="18" charset="0"/>
-            </a:endParaRPr>
-          </a:p>
-        </p:txBody>
-      </p:sp>
-    </p:spTree>
-    <p:extLst>
-      <p:ext uri="{BB962C8B-B14F-4D97-AF65-F5344CB8AC3E}">
-        <p14:creationId xmlns:p14="http://schemas.microsoft.com/office/powerpoint/2010/main" val="3485023015"/>
-      </p:ext>
-    </p:extLst>
-  </p:cSld>
-  <p:clrMapOvr>
-    <a:masterClrMapping/>
-  </p:clrMapOvr>
-</p:sld>
-</file>
-
-<file path=ppt/slides/slide26.xml><?xml version="1.0" encoding="utf-8"?>
-<p:sld xmlns:a="http://schemas.openxmlformats.org/drawingml/2006/main" xmlns:r="http://schemas.openxmlformats.org/officeDocument/2006/relationships" xmlns:p="http://schemas.openxmlformats.org/presentationml/2006/main">
-  <p:cSld>
-    <p:spTree>
-      <p:nvGrpSpPr>
-        <p:cNvPr id="1" name=""/>
-        <p:cNvGrpSpPr/>
-        <p:nvPr/>
-      </p:nvGrpSpPr>
-      <p:grpSpPr>
-        <a:xfrm>
-          <a:off x="0" y="0"/>
-          <a:ext cx="0" cy="0"/>
-          <a:chOff x="0" y="0"/>
-          <a:chExt cx="0" cy="0"/>
-        </a:xfrm>
-      </p:grpSpPr>
-      <p:sp>
-        <p:nvSpPr>
-          <p:cNvPr id="2" name="Footer Placeholder 1"/>
-          <p:cNvSpPr>
-            <a:spLocks noGrp="1"/>
-          </p:cNvSpPr>
-          <p:nvPr>
-            <p:ph type="ftr" sz="quarter" idx="3"/>
-          </p:nvPr>
-        </p:nvSpPr>
-        <p:spPr/>
-        <p:txBody>
-          <a:bodyPr/>
-          <a:lstStyle/>
-          <a:p>
-            <a:r>
-              <a:rPr lang="en-US"/>
-              <a:t>Dept. of CSE | GAT | 2025-26                                                                                                           CSEP23605</a:t>
-            </a:r>
-            <a:endParaRPr lang="en-IN" dirty="0"/>
-          </a:p>
-        </p:txBody>
-      </p:sp>
-      <p:sp>
-        <p:nvSpPr>
-          <p:cNvPr id="3" name="Slide Number Placeholder 2"/>
-          <p:cNvSpPr>
-            <a:spLocks noGrp="1"/>
-          </p:cNvSpPr>
-          <p:nvPr>
-            <p:ph type="sldNum" sz="quarter" idx="4"/>
-          </p:nvPr>
-        </p:nvSpPr>
-        <p:spPr/>
-        <p:txBody>
-          <a:bodyPr/>
-          <a:lstStyle/>
-          <a:p>
-            <a:fld id="{FFAE6D68-FB99-4243-9CC1-93FAA8C005BC}" type="slidenum">
-              <a:rPr lang="en-IN" smtClean="0"/>
-              <a:pPr/>
-              <a:t>26</a:t>
-            </a:fld>
-            <a:endParaRPr lang="en-IN"/>
-          </a:p>
-        </p:txBody>
-      </p:sp>
-      <p:sp>
-        <p:nvSpPr>
-          <p:cNvPr id="4" name="TextBox 3">
-            <a:extLst>
-              <a:ext uri="{FF2B5EF4-FFF2-40B4-BE49-F238E27FC236}">
-                <a16:creationId xmlns:a16="http://schemas.microsoft.com/office/drawing/2014/main" id="{A2D65176-27C0-6A9C-1D22-589841C6C443}"/>
-              </a:ext>
-            </a:extLst>
-          </p:cNvPr>
-          <p:cNvSpPr txBox="1"/>
-          <p:nvPr/>
-        </p:nvSpPr>
-        <p:spPr>
-          <a:xfrm>
-            <a:off x="2580264" y="2735011"/>
-            <a:ext cx="6595110" cy="707886"/>
-          </a:xfrm>
-          <a:prstGeom prst="rect">
-            <a:avLst/>
-          </a:prstGeom>
-          <a:noFill/>
-        </p:spPr>
-        <p:txBody>
-          <a:bodyPr wrap="square" rtlCol="0">
-            <a:spAutoFit/>
-          </a:bodyPr>
-          <a:lstStyle/>
-          <a:p>
-            <a:pPr algn="ctr"/>
-            <a:r>
-              <a:rPr lang="en-US" sz="4000" b="1" dirty="0">
-                <a:latin typeface="Cambria" panose="02040503050406030204" pitchFamily="18" charset="0"/>
-                <a:ea typeface="Cambria" panose="02040503050406030204" pitchFamily="18" charset="0"/>
-              </a:rPr>
-              <a:t>Thank You</a:t>
-            </a:r>
-            <a:endParaRPr lang="en-IN" sz="4000" b="1" dirty="0">
-              <a:latin typeface="Cambria" panose="02040503050406030204" pitchFamily="18" charset="0"/>
-              <a:ea typeface="Cambria" panose="02040503050406030204" pitchFamily="18" charset="0"/>
-            </a:endParaRPr>
-          </a:p>
-        </p:txBody>
-      </p:sp>
-    </p:spTree>
-    <p:extLst>
-      <p:ext uri="{BB962C8B-B14F-4D97-AF65-F5344CB8AC3E}">
-        <p14:creationId xmlns:p14="http://schemas.microsoft.com/office/powerpoint/2010/main" val="3938483354"/>
       </p:ext>
     </p:extLst>
   </p:cSld>
@@ -11180,6 +12968,246 @@
     <p:extLst>
       <p:ext uri="{BB962C8B-B14F-4D97-AF65-F5344CB8AC3E}">
         <p14:creationId xmlns:p14="http://schemas.microsoft.com/office/powerpoint/2010/main" val="3297626928"/>
+      </p:ext>
+    </p:extLst>
+  </p:cSld>
+  <p:clrMapOvr>
+    <a:masterClrMapping/>
+  </p:clrMapOvr>
+</p:sld>
+</file>
+
+<file path=ppt/slides/slide30.xml><?xml version="1.0" encoding="utf-8"?>
+<p:sld xmlns:a="http://schemas.openxmlformats.org/drawingml/2006/main" xmlns:r="http://schemas.openxmlformats.org/officeDocument/2006/relationships" xmlns:p="http://schemas.openxmlformats.org/presentationml/2006/main">
+  <p:cSld>
+    <p:spTree>
+      <p:nvGrpSpPr>
+        <p:cNvPr id="1" name=""/>
+        <p:cNvGrpSpPr/>
+        <p:nvPr/>
+      </p:nvGrpSpPr>
+      <p:grpSpPr>
+        <a:xfrm>
+          <a:off x="0" y="0"/>
+          <a:ext cx="0" cy="0"/>
+          <a:chOff x="0" y="0"/>
+          <a:chExt cx="0" cy="0"/>
+        </a:xfrm>
+      </p:grpSpPr>
+      <p:sp>
+        <p:nvSpPr>
+          <p:cNvPr id="2" name="Footer Placeholder 1"/>
+          <p:cNvSpPr>
+            <a:spLocks noGrp="1"/>
+          </p:cNvSpPr>
+          <p:nvPr>
+            <p:ph type="ftr" sz="quarter" idx="3"/>
+          </p:nvPr>
+        </p:nvSpPr>
+        <p:spPr/>
+        <p:txBody>
+          <a:bodyPr/>
+          <a:lstStyle/>
+          <a:p>
+            <a:r>
+              <a:rPr lang="en-US"/>
+              <a:t>Dept. of CSE | GAT | 2025-26                                                                                                           CSEP23605</a:t>
+            </a:r>
+            <a:endParaRPr lang="en-IN" dirty="0"/>
+          </a:p>
+        </p:txBody>
+      </p:sp>
+      <p:sp>
+        <p:nvSpPr>
+          <p:cNvPr id="3" name="Slide Number Placeholder 2"/>
+          <p:cNvSpPr>
+            <a:spLocks noGrp="1"/>
+          </p:cNvSpPr>
+          <p:nvPr>
+            <p:ph type="sldNum" sz="quarter" idx="4"/>
+          </p:nvPr>
+        </p:nvSpPr>
+        <p:spPr/>
+        <p:txBody>
+          <a:bodyPr/>
+          <a:lstStyle/>
+          <a:p>
+            <a:fld id="{FFAE6D68-FB99-4243-9CC1-93FAA8C005BC}" type="slidenum">
+              <a:rPr lang="en-IN" smtClean="0"/>
+              <a:pPr/>
+              <a:t>30</a:t>
+            </a:fld>
+            <a:endParaRPr lang="en-IN"/>
+          </a:p>
+        </p:txBody>
+      </p:sp>
+      <p:sp>
+        <p:nvSpPr>
+          <p:cNvPr id="4" name="TextBox 3">
+            <a:extLst>
+              <a:ext uri="{FF2B5EF4-FFF2-40B4-BE49-F238E27FC236}">
+                <a16:creationId xmlns:a16="http://schemas.microsoft.com/office/drawing/2014/main" id="{A2D65176-27C0-6A9C-1D22-589841C6C443}"/>
+              </a:ext>
+            </a:extLst>
+          </p:cNvPr>
+          <p:cNvSpPr txBox="1"/>
+          <p:nvPr/>
+        </p:nvSpPr>
+        <p:spPr>
+          <a:xfrm>
+            <a:off x="2730389" y="2775955"/>
+            <a:ext cx="6595110" cy="707886"/>
+          </a:xfrm>
+          <a:prstGeom prst="rect">
+            <a:avLst/>
+          </a:prstGeom>
+          <a:noFill/>
+        </p:spPr>
+        <p:txBody>
+          <a:bodyPr wrap="square" rtlCol="0">
+            <a:spAutoFit/>
+          </a:bodyPr>
+          <a:lstStyle/>
+          <a:p>
+            <a:pPr algn="ctr"/>
+            <a:r>
+              <a:rPr lang="en-US" sz="4000" b="1" dirty="0">
+                <a:latin typeface="Cambria" panose="02040503050406030204" pitchFamily="18" charset="0"/>
+                <a:ea typeface="Cambria" panose="02040503050406030204" pitchFamily="18" charset="0"/>
+              </a:rPr>
+              <a:t>Q &amp; A</a:t>
+            </a:r>
+            <a:endParaRPr lang="en-IN" sz="4000" b="1" dirty="0">
+              <a:latin typeface="Cambria" panose="02040503050406030204" pitchFamily="18" charset="0"/>
+              <a:ea typeface="Cambria" panose="02040503050406030204" pitchFamily="18" charset="0"/>
+            </a:endParaRPr>
+          </a:p>
+        </p:txBody>
+      </p:sp>
+    </p:spTree>
+    <p:extLst>
+      <p:ext uri="{BB962C8B-B14F-4D97-AF65-F5344CB8AC3E}">
+        <p14:creationId xmlns:p14="http://schemas.microsoft.com/office/powerpoint/2010/main" val="3485023015"/>
+      </p:ext>
+    </p:extLst>
+  </p:cSld>
+  <p:clrMapOvr>
+    <a:masterClrMapping/>
+  </p:clrMapOvr>
+</p:sld>
+</file>
+
+<file path=ppt/slides/slide31.xml><?xml version="1.0" encoding="utf-8"?>
+<p:sld xmlns:a="http://schemas.openxmlformats.org/drawingml/2006/main" xmlns:r="http://schemas.openxmlformats.org/officeDocument/2006/relationships" xmlns:p="http://schemas.openxmlformats.org/presentationml/2006/main">
+  <p:cSld>
+    <p:spTree>
+      <p:nvGrpSpPr>
+        <p:cNvPr id="1" name=""/>
+        <p:cNvGrpSpPr/>
+        <p:nvPr/>
+      </p:nvGrpSpPr>
+      <p:grpSpPr>
+        <a:xfrm>
+          <a:off x="0" y="0"/>
+          <a:ext cx="0" cy="0"/>
+          <a:chOff x="0" y="0"/>
+          <a:chExt cx="0" cy="0"/>
+        </a:xfrm>
+      </p:grpSpPr>
+      <p:sp>
+        <p:nvSpPr>
+          <p:cNvPr id="2" name="Footer Placeholder 1"/>
+          <p:cNvSpPr>
+            <a:spLocks noGrp="1"/>
+          </p:cNvSpPr>
+          <p:nvPr>
+            <p:ph type="ftr" sz="quarter" idx="3"/>
+          </p:nvPr>
+        </p:nvSpPr>
+        <p:spPr/>
+        <p:txBody>
+          <a:bodyPr/>
+          <a:lstStyle/>
+          <a:p>
+            <a:r>
+              <a:rPr lang="en-US"/>
+              <a:t>Dept. of CSE | GAT | 2025-26                                                                                                           CSEP23605</a:t>
+            </a:r>
+            <a:endParaRPr lang="en-IN" dirty="0"/>
+          </a:p>
+        </p:txBody>
+      </p:sp>
+      <p:sp>
+        <p:nvSpPr>
+          <p:cNvPr id="3" name="Slide Number Placeholder 2"/>
+          <p:cNvSpPr>
+            <a:spLocks noGrp="1"/>
+          </p:cNvSpPr>
+          <p:nvPr>
+            <p:ph type="sldNum" sz="quarter" idx="4"/>
+          </p:nvPr>
+        </p:nvSpPr>
+        <p:spPr/>
+        <p:txBody>
+          <a:bodyPr/>
+          <a:lstStyle/>
+          <a:p>
+            <a:fld id="{FFAE6D68-FB99-4243-9CC1-93FAA8C005BC}" type="slidenum">
+              <a:rPr lang="en-IN" smtClean="0"/>
+              <a:pPr/>
+              <a:t>31</a:t>
+            </a:fld>
+            <a:endParaRPr lang="en-IN"/>
+          </a:p>
+        </p:txBody>
+      </p:sp>
+      <p:sp>
+        <p:nvSpPr>
+          <p:cNvPr id="4" name="TextBox 3">
+            <a:extLst>
+              <a:ext uri="{FF2B5EF4-FFF2-40B4-BE49-F238E27FC236}">
+                <a16:creationId xmlns:a16="http://schemas.microsoft.com/office/drawing/2014/main" id="{A2D65176-27C0-6A9C-1D22-589841C6C443}"/>
+              </a:ext>
+            </a:extLst>
+          </p:cNvPr>
+          <p:cNvSpPr txBox="1"/>
+          <p:nvPr/>
+        </p:nvSpPr>
+        <p:spPr>
+          <a:xfrm>
+            <a:off x="2580264" y="2735011"/>
+            <a:ext cx="6595110" cy="707886"/>
+          </a:xfrm>
+          <a:prstGeom prst="rect">
+            <a:avLst/>
+          </a:prstGeom>
+          <a:noFill/>
+        </p:spPr>
+        <p:txBody>
+          <a:bodyPr wrap="square" rtlCol="0">
+            <a:spAutoFit/>
+          </a:bodyPr>
+          <a:lstStyle/>
+          <a:p>
+            <a:pPr algn="ctr"/>
+            <a:r>
+              <a:rPr lang="en-US" sz="4000" b="1" dirty="0">
+                <a:latin typeface="Cambria" panose="02040503050406030204" pitchFamily="18" charset="0"/>
+                <a:ea typeface="Cambria" panose="02040503050406030204" pitchFamily="18" charset="0"/>
+              </a:rPr>
+              <a:t>Thank You</a:t>
+            </a:r>
+            <a:endParaRPr lang="en-IN" sz="4000" b="1" dirty="0">
+              <a:latin typeface="Cambria" panose="02040503050406030204" pitchFamily="18" charset="0"/>
+              <a:ea typeface="Cambria" panose="02040503050406030204" pitchFamily="18" charset="0"/>
+            </a:endParaRPr>
+          </a:p>
+        </p:txBody>
+      </p:sp>
+    </p:spTree>
+    <p:extLst>
+      <p:ext uri="{BB962C8B-B14F-4D97-AF65-F5344CB8AC3E}">
+        <p14:creationId xmlns:p14="http://schemas.microsoft.com/office/powerpoint/2010/main" val="3938483354"/>
       </p:ext>
     </p:extLst>
   </p:cSld>

</xml_diff>

<commit_message>
Update CSEP23605 Review 1.pptx with revised content
</commit_message>
<xml_diff>
--- a/Documentation/PPT/CSEP23605 Review 1.pptx
+++ b/Documentation/PPT/CSEP23605 Review 1.pptx
@@ -3647,7 +3647,7 @@
           <a:p>
             <a:pPr algn="ctr"/>
             <a:r>
-              <a:rPr lang="en-US" sz="2000" b="1" dirty="0">
+              <a:rPr lang="en-US" sz="2000" b="1">
                 <a:solidFill>
                   <a:srgbClr val="002060"/>
                 </a:solidFill>
@@ -3655,7 +3655,7 @@
                 <a:ea typeface="Cambria" panose="02040503050406030204" pitchFamily="18" charset="0"/>
                 <a:cs typeface="Times New Roman" panose="02020603050405020304" pitchFamily="18" charset="0"/>
               </a:rPr>
-              <a:t>Review 1</a:t>
+              <a:t>Review 2</a:t>
             </a:r>
             <a:endParaRPr lang="en-IN" sz="2000" b="1" dirty="0">
               <a:solidFill>

</xml_diff>